<commit_message>
lecture for 1st topic
</commit_message>
<xml_diff>
--- a/01-CourseIntroduction/CourseIntroduction.pptx
+++ b/01-CourseIntroduction/CourseIntroduction.pptx
@@ -5,10 +5,10 @@
     <p:sldMasterId id="2147484995" r:id="rId1"/>
   </p:sldMasterIdLst>
   <p:notesMasterIdLst>
-    <p:notesMasterId r:id="rId23"/>
+    <p:notesMasterId r:id="rId22"/>
   </p:notesMasterIdLst>
   <p:handoutMasterIdLst>
-    <p:handoutMasterId r:id="rId24"/>
+    <p:handoutMasterId r:id="rId23"/>
   </p:handoutMasterIdLst>
   <p:sldIdLst>
     <p:sldId id="256" r:id="rId2"/>
@@ -16,22 +16,21 @@
     <p:sldId id="327" r:id="rId4"/>
     <p:sldId id="306" r:id="rId5"/>
     <p:sldId id="304" r:id="rId6"/>
-    <p:sldId id="342" r:id="rId7"/>
-    <p:sldId id="343" r:id="rId8"/>
-    <p:sldId id="307" r:id="rId9"/>
-    <p:sldId id="320" r:id="rId10"/>
-    <p:sldId id="291" r:id="rId11"/>
-    <p:sldId id="316" r:id="rId12"/>
-    <p:sldId id="317" r:id="rId13"/>
-    <p:sldId id="318" r:id="rId14"/>
-    <p:sldId id="319" r:id="rId15"/>
-    <p:sldId id="335" r:id="rId16"/>
-    <p:sldId id="333" r:id="rId17"/>
-    <p:sldId id="337" r:id="rId18"/>
-    <p:sldId id="334" r:id="rId19"/>
-    <p:sldId id="323" r:id="rId20"/>
-    <p:sldId id="340" r:id="rId21"/>
-    <p:sldId id="312" r:id="rId22"/>
+    <p:sldId id="343" r:id="rId7"/>
+    <p:sldId id="307" r:id="rId8"/>
+    <p:sldId id="320" r:id="rId9"/>
+    <p:sldId id="291" r:id="rId10"/>
+    <p:sldId id="316" r:id="rId11"/>
+    <p:sldId id="317" r:id="rId12"/>
+    <p:sldId id="318" r:id="rId13"/>
+    <p:sldId id="319" r:id="rId14"/>
+    <p:sldId id="335" r:id="rId15"/>
+    <p:sldId id="333" r:id="rId16"/>
+    <p:sldId id="337" r:id="rId17"/>
+    <p:sldId id="334" r:id="rId18"/>
+    <p:sldId id="323" r:id="rId19"/>
+    <p:sldId id="340" r:id="rId20"/>
+    <p:sldId id="312" r:id="rId21"/>
   </p:sldIdLst>
   <p:sldSz cx="12192000" cy="6858000"/>
   <p:notesSz cx="6888163" cy="10020300"/>
@@ -141,7 +140,7 @@
 <file path=ppt/revisionInfo.xml><?xml version="1.0" encoding="utf-8"?>
 <p1510:revInfo xmlns:a="http://schemas.openxmlformats.org/drawingml/2006/main" xmlns:r="http://schemas.openxmlformats.org/officeDocument/2006/relationships" xmlns:p1510="http://schemas.microsoft.com/office/powerpoint/2015/10/main">
   <p1510:revLst>
-    <p1510:client id="{23EEAE0B-FDAB-46BF-B073-53A3CB61A1BE}" v="10" dt="2024-09-17T12:56:32.919"/>
+    <p1510:client id="{A4F0ECAB-B2F0-45E0-B7F9-20493D3A71C5}" v="1" dt="2026-10-03T15:38:29.904"/>
   </p1510:revLst>
 </p1510:revInfo>
 </file>
@@ -149,427 +148,20 @@
 <file path=ppt/changesInfos/changesInfo1.xml><?xml version="1.0" encoding="utf-8"?>
 <pc:chgInfo xmlns:a="http://schemas.openxmlformats.org/drawingml/2006/main" xmlns:r="http://schemas.openxmlformats.org/officeDocument/2006/relationships" xmlns:ac="http://schemas.microsoft.com/office/drawing/2013/main/command" xmlns:pc="http://schemas.microsoft.com/office/powerpoint/2013/main/command">
   <pc:docChgLst>
-    <pc:chgData name="Janusz Stal" userId="570fe9c4-9123-4bde-9755-2a9767a29a9c" providerId="ADAL" clId="{F518F96C-0279-4C88-9D30-7163CFBA3673}"/>
-    <pc:docChg chg="undo custSel modSld modNotesMaster modHandout modShowInfo">
-      <pc:chgData name="Janusz Stal" userId="570fe9c4-9123-4bde-9755-2a9767a29a9c" providerId="ADAL" clId="{F518F96C-0279-4C88-9D30-7163CFBA3673}" dt="2023-10-27T21:23:47.580" v="209" actId="2744"/>
+    <pc:chgData name="Janusz Stal" userId="570fe9c4-9123-4bde-9755-2a9767a29a9c" providerId="ADAL" clId="{93B0BD34-580E-4F7F-A301-D1F6EE30DB68}"/>
+    <pc:docChg chg="undo custSel delSld modSld">
+      <pc:chgData name="Janusz Stal" userId="570fe9c4-9123-4bde-9755-2a9767a29a9c" providerId="ADAL" clId="{93B0BD34-580E-4F7F-A301-D1F6EE30DB68}" dt="2026-10-03T16:34:16.774" v="98" actId="20577"/>
       <pc:docMkLst>
         <pc:docMk/>
       </pc:docMkLst>
-      <pc:sldChg chg="delSp mod modTransition delAnim modNotesTx">
-        <pc:chgData name="Janusz Stal" userId="570fe9c4-9123-4bde-9755-2a9767a29a9c" providerId="ADAL" clId="{F518F96C-0279-4C88-9D30-7163CFBA3673}" dt="2023-09-29T08:57:09.833" v="31" actId="20577"/>
-        <pc:sldMkLst>
-          <pc:docMk/>
-          <pc:sldMk cId="748555187" sldId="256"/>
-        </pc:sldMkLst>
-        <pc:picChg chg="del">
-          <ac:chgData name="Janusz Stal" userId="570fe9c4-9123-4bde-9755-2a9767a29a9c" providerId="ADAL" clId="{F518F96C-0279-4C88-9D30-7163CFBA3673}" dt="2023-09-22T12:40:34.527" v="0" actId="478"/>
-          <ac:picMkLst>
-            <pc:docMk/>
-            <pc:sldMk cId="748555187" sldId="256"/>
-            <ac:picMk id="5" creationId="{8B3735AB-84EE-B5C9-B719-9BA89864354A}"/>
-          </ac:picMkLst>
-        </pc:picChg>
-      </pc:sldChg>
-      <pc:sldChg chg="delSp mod modTransition delAnim modNotesTx">
-        <pc:chgData name="Janusz Stal" userId="570fe9c4-9123-4bde-9755-2a9767a29a9c" providerId="ADAL" clId="{F518F96C-0279-4C88-9D30-7163CFBA3673}" dt="2023-09-29T09:12:50.407" v="143" actId="6549"/>
-        <pc:sldMkLst>
-          <pc:docMk/>
-          <pc:sldMk cId="3207883656" sldId="291"/>
-        </pc:sldMkLst>
-        <pc:picChg chg="del">
-          <ac:chgData name="Janusz Stal" userId="570fe9c4-9123-4bde-9755-2a9767a29a9c" providerId="ADAL" clId="{F518F96C-0279-4C88-9D30-7163CFBA3673}" dt="2023-09-22T12:40:57.233" v="13" actId="478"/>
-          <ac:picMkLst>
-            <pc:docMk/>
-            <pc:sldMk cId="3207883656" sldId="291"/>
-            <ac:picMk id="2" creationId="{EBA8F777-5D0F-3D38-9162-656F6DDF1225}"/>
-          </ac:picMkLst>
-        </pc:picChg>
-      </pc:sldChg>
-      <pc:sldChg chg="delSp mod modTransition delAnim modNotesTx">
-        <pc:chgData name="Janusz Stal" userId="570fe9c4-9123-4bde-9755-2a9767a29a9c" providerId="ADAL" clId="{F518F96C-0279-4C88-9D30-7163CFBA3673}" dt="2023-09-29T08:58:56.117" v="40" actId="6549"/>
-        <pc:sldMkLst>
-          <pc:docMk/>
-          <pc:sldMk cId="3285343587" sldId="292"/>
-        </pc:sldMkLst>
-        <pc:picChg chg="del">
-          <ac:chgData name="Janusz Stal" userId="570fe9c4-9123-4bde-9755-2a9767a29a9c" providerId="ADAL" clId="{F518F96C-0279-4C88-9D30-7163CFBA3673}" dt="2023-09-22T12:40:37.612" v="1" actId="478"/>
-          <ac:picMkLst>
-            <pc:docMk/>
-            <pc:sldMk cId="3285343587" sldId="292"/>
-            <ac:picMk id="5" creationId="{0BCF18DE-BBA2-2D96-A0A3-9F31A602FEC5}"/>
-          </ac:picMkLst>
-        </pc:picChg>
-      </pc:sldChg>
-      <pc:sldChg chg="delSp mod modTransition delAnim modNotesTx">
-        <pc:chgData name="Janusz Stal" userId="570fe9c4-9123-4bde-9755-2a9767a29a9c" providerId="ADAL" clId="{F518F96C-0279-4C88-9D30-7163CFBA3673}" dt="2023-09-29T09:04:37.110" v="69" actId="20577"/>
-        <pc:sldMkLst>
-          <pc:docMk/>
-          <pc:sldMk cId="665344467" sldId="304"/>
-        </pc:sldMkLst>
-        <pc:picChg chg="del">
-          <ac:chgData name="Janusz Stal" userId="570fe9c4-9123-4bde-9755-2a9767a29a9c" providerId="ADAL" clId="{F518F96C-0279-4C88-9D30-7163CFBA3673}" dt="2023-09-22T12:40:42.651" v="4" actId="478"/>
-          <ac:picMkLst>
-            <pc:docMk/>
-            <pc:sldMk cId="665344467" sldId="304"/>
-            <ac:picMk id="2" creationId="{0356E45F-532D-90D5-73D4-F23F962DA005}"/>
-          </ac:picMkLst>
-        </pc:picChg>
-      </pc:sldChg>
-      <pc:sldChg chg="delSp mod modTransition delAnim modNotesTx">
-        <pc:chgData name="Janusz Stal" userId="570fe9c4-9123-4bde-9755-2a9767a29a9c" providerId="ADAL" clId="{F518F96C-0279-4C88-9D30-7163CFBA3673}" dt="2023-09-29T09:02:13.337" v="42"/>
-        <pc:sldMkLst>
-          <pc:docMk/>
-          <pc:sldMk cId="995346915" sldId="306"/>
-        </pc:sldMkLst>
-        <pc:picChg chg="del">
-          <ac:chgData name="Janusz Stal" userId="570fe9c4-9123-4bde-9755-2a9767a29a9c" providerId="ADAL" clId="{F518F96C-0279-4C88-9D30-7163CFBA3673}" dt="2023-09-22T12:40:41.118" v="3" actId="478"/>
-          <ac:picMkLst>
-            <pc:docMk/>
-            <pc:sldMk cId="995346915" sldId="306"/>
-            <ac:picMk id="2" creationId="{6DC6E549-BCF2-BFFA-9722-CA99A9022EB1}"/>
-          </ac:picMkLst>
-        </pc:picChg>
-      </pc:sldChg>
-      <pc:sldChg chg="delSp mod modTransition delAnim modNotesTx">
-        <pc:chgData name="Janusz Stal" userId="570fe9c4-9123-4bde-9755-2a9767a29a9c" providerId="ADAL" clId="{F518F96C-0279-4C88-9D30-7163CFBA3673}" dt="2023-09-29T09:08:44.414" v="126" actId="6549"/>
-        <pc:sldMkLst>
-          <pc:docMk/>
-          <pc:sldMk cId="481222839" sldId="307"/>
-        </pc:sldMkLst>
-        <pc:picChg chg="del">
-          <ac:chgData name="Janusz Stal" userId="570fe9c4-9123-4bde-9755-2a9767a29a9c" providerId="ADAL" clId="{F518F96C-0279-4C88-9D30-7163CFBA3673}" dt="2023-09-22T12:40:45.708" v="6" actId="478"/>
-          <ac:picMkLst>
-            <pc:docMk/>
-            <pc:sldMk cId="481222839" sldId="307"/>
-            <ac:picMk id="2" creationId="{3C544173-EEEC-2786-CB7A-5D11EAD23DDE}"/>
-          </ac:picMkLst>
-        </pc:picChg>
-      </pc:sldChg>
-      <pc:sldChg chg="delSp mod modTransition delAnim modNotesTx">
-        <pc:chgData name="Janusz Stal" userId="570fe9c4-9123-4bde-9755-2a9767a29a9c" providerId="ADAL" clId="{F518F96C-0279-4C88-9D30-7163CFBA3673}" dt="2023-09-29T09:12:22.247" v="138" actId="20577"/>
-        <pc:sldMkLst>
-          <pc:docMk/>
-          <pc:sldMk cId="3376502272" sldId="312"/>
-        </pc:sldMkLst>
-        <pc:picChg chg="del">
-          <ac:chgData name="Janusz Stal" userId="570fe9c4-9123-4bde-9755-2a9767a29a9c" providerId="ADAL" clId="{F518F96C-0279-4C88-9D30-7163CFBA3673}" dt="2023-09-22T12:40:54.109" v="11" actId="478"/>
-          <ac:picMkLst>
-            <pc:docMk/>
-            <pc:sldMk cId="3376502272" sldId="312"/>
-            <ac:picMk id="6" creationId="{0BA07B33-E7BD-8229-FCD6-A8B82322567A}"/>
-          </ac:picMkLst>
-        </pc:picChg>
-      </pc:sldChg>
-      <pc:sldChg chg="delSp mod modTransition delAnim modNotesTx">
-        <pc:chgData name="Janusz Stal" userId="570fe9c4-9123-4bde-9755-2a9767a29a9c" providerId="ADAL" clId="{F518F96C-0279-4C88-9D30-7163CFBA3673}" dt="2023-09-29T09:14:06.518" v="164" actId="20577"/>
-        <pc:sldMkLst>
-          <pc:docMk/>
-          <pc:sldMk cId="1144236073" sldId="316"/>
-        </pc:sldMkLst>
-        <pc:picChg chg="del">
-          <ac:chgData name="Janusz Stal" userId="570fe9c4-9123-4bde-9755-2a9767a29a9c" providerId="ADAL" clId="{F518F96C-0279-4C88-9D30-7163CFBA3673}" dt="2023-09-22T12:40:58.823" v="14" actId="478"/>
-          <ac:picMkLst>
-            <pc:docMk/>
-            <pc:sldMk cId="1144236073" sldId="316"/>
-            <ac:picMk id="5" creationId="{FFB1FFB4-ADA5-9049-EE0C-243E7ACF40BD}"/>
-          </ac:picMkLst>
-        </pc:picChg>
-      </pc:sldChg>
-      <pc:sldChg chg="delSp mod modTransition delAnim modNotesTx">
-        <pc:chgData name="Janusz Stal" userId="570fe9c4-9123-4bde-9755-2a9767a29a9c" providerId="ADAL" clId="{F518F96C-0279-4C88-9D30-7163CFBA3673}" dt="2023-09-29T09:15:10.516" v="176" actId="20577"/>
-        <pc:sldMkLst>
-          <pc:docMk/>
-          <pc:sldMk cId="2533284800" sldId="317"/>
-        </pc:sldMkLst>
-        <pc:picChg chg="del">
-          <ac:chgData name="Janusz Stal" userId="570fe9c4-9123-4bde-9755-2a9767a29a9c" providerId="ADAL" clId="{F518F96C-0279-4C88-9D30-7163CFBA3673}" dt="2023-09-22T12:41:00.317" v="15" actId="478"/>
-          <ac:picMkLst>
-            <pc:docMk/>
-            <pc:sldMk cId="2533284800" sldId="317"/>
-            <ac:picMk id="5" creationId="{BF70DC6A-6691-9177-0F48-71AE5F0B8050}"/>
-          </ac:picMkLst>
-        </pc:picChg>
-      </pc:sldChg>
-      <pc:sldChg chg="delSp mod modTransition delAnim">
-        <pc:chgData name="Janusz Stal" userId="570fe9c4-9123-4bde-9755-2a9767a29a9c" providerId="ADAL" clId="{F518F96C-0279-4C88-9D30-7163CFBA3673}" dt="2023-09-26T08:38:24.318" v="26"/>
-        <pc:sldMkLst>
-          <pc:docMk/>
-          <pc:sldMk cId="1234291028" sldId="318"/>
-        </pc:sldMkLst>
-        <pc:picChg chg="del">
-          <ac:chgData name="Janusz Stal" userId="570fe9c4-9123-4bde-9755-2a9767a29a9c" providerId="ADAL" clId="{F518F96C-0279-4C88-9D30-7163CFBA3673}" dt="2023-09-22T12:41:01.709" v="16" actId="478"/>
-          <ac:picMkLst>
-            <pc:docMk/>
-            <pc:sldMk cId="1234291028" sldId="318"/>
-            <ac:picMk id="5" creationId="{6936D496-0204-CF78-86C1-8B57028D63CF}"/>
-          </ac:picMkLst>
-        </pc:picChg>
-      </pc:sldChg>
-      <pc:sldChg chg="delSp mod modTransition delAnim modNotesTx">
-        <pc:chgData name="Janusz Stal" userId="570fe9c4-9123-4bde-9755-2a9767a29a9c" providerId="ADAL" clId="{F518F96C-0279-4C88-9D30-7163CFBA3673}" dt="2023-09-29T09:15:46.548" v="179" actId="20577"/>
-        <pc:sldMkLst>
-          <pc:docMk/>
-          <pc:sldMk cId="3984066826" sldId="319"/>
-        </pc:sldMkLst>
-        <pc:picChg chg="del">
-          <ac:chgData name="Janusz Stal" userId="570fe9c4-9123-4bde-9755-2a9767a29a9c" providerId="ADAL" clId="{F518F96C-0279-4C88-9D30-7163CFBA3673}" dt="2023-09-22T12:41:03.541" v="17" actId="478"/>
-          <ac:picMkLst>
-            <pc:docMk/>
-            <pc:sldMk cId="3984066826" sldId="319"/>
-            <ac:picMk id="5" creationId="{E553C499-EAF8-299B-8482-09AFB91FAEC9}"/>
-          </ac:picMkLst>
-        </pc:picChg>
-      </pc:sldChg>
-      <pc:sldChg chg="delSp mod modTransition delAnim">
-        <pc:chgData name="Janusz Stal" userId="570fe9c4-9123-4bde-9755-2a9767a29a9c" providerId="ADAL" clId="{F518F96C-0279-4C88-9D30-7163CFBA3673}" dt="2023-09-26T08:38:24.318" v="26"/>
-        <pc:sldMkLst>
-          <pc:docMk/>
-          <pc:sldMk cId="1005848108" sldId="320"/>
-        </pc:sldMkLst>
-        <pc:picChg chg="del">
-          <ac:chgData name="Janusz Stal" userId="570fe9c4-9123-4bde-9755-2a9767a29a9c" providerId="ADAL" clId="{F518F96C-0279-4C88-9D30-7163CFBA3673}" dt="2023-09-22T12:40:55.722" v="12" actId="478"/>
-          <ac:picMkLst>
-            <pc:docMk/>
-            <pc:sldMk cId="1005848108" sldId="320"/>
-            <ac:picMk id="5" creationId="{1C8E13C6-83AB-87FD-C8AF-A06A47ACDF0E}"/>
-          </ac:picMkLst>
-        </pc:picChg>
-      </pc:sldChg>
-      <pc:sldChg chg="delSp mod modTransition delAnim">
-        <pc:chgData name="Janusz Stal" userId="570fe9c4-9123-4bde-9755-2a9767a29a9c" providerId="ADAL" clId="{F518F96C-0279-4C88-9D30-7163CFBA3673}" dt="2023-09-26T08:38:24.318" v="26"/>
-        <pc:sldMkLst>
-          <pc:docMk/>
-          <pc:sldMk cId="2525688714" sldId="323"/>
-        </pc:sldMkLst>
-        <pc:picChg chg="del">
-          <ac:chgData name="Janusz Stal" userId="570fe9c4-9123-4bde-9755-2a9767a29a9c" providerId="ADAL" clId="{F518F96C-0279-4C88-9D30-7163CFBA3673}" dt="2023-09-22T12:41:13.853" v="23" actId="478"/>
-          <ac:picMkLst>
-            <pc:docMk/>
-            <pc:sldMk cId="2525688714" sldId="323"/>
-            <ac:picMk id="5" creationId="{6D0BE731-6A4A-61A0-EB90-D52AE9219AEF}"/>
-          </ac:picMkLst>
-        </pc:picChg>
-      </pc:sldChg>
-      <pc:sldChg chg="delSp mod modTransition delAnim modNotesTx">
-        <pc:chgData name="Janusz Stal" userId="570fe9c4-9123-4bde-9755-2a9767a29a9c" providerId="ADAL" clId="{F518F96C-0279-4C88-9D30-7163CFBA3673}" dt="2023-09-29T09:00:16.234" v="41"/>
-        <pc:sldMkLst>
-          <pc:docMk/>
-          <pc:sldMk cId="2130001478" sldId="327"/>
-        </pc:sldMkLst>
-        <pc:picChg chg="del">
-          <ac:chgData name="Janusz Stal" userId="570fe9c4-9123-4bde-9755-2a9767a29a9c" providerId="ADAL" clId="{F518F96C-0279-4C88-9D30-7163CFBA3673}" dt="2023-09-22T12:40:39.399" v="2" actId="478"/>
-          <ac:picMkLst>
-            <pc:docMk/>
-            <pc:sldMk cId="2130001478" sldId="327"/>
-            <ac:picMk id="5" creationId="{D3DB8516-2008-7DB6-0134-E5C6A15A15AA}"/>
-          </ac:picMkLst>
-        </pc:picChg>
-      </pc:sldChg>
-      <pc:sldChg chg="delSp mod modTransition delAnim">
-        <pc:chgData name="Janusz Stal" userId="570fe9c4-9123-4bde-9755-2a9767a29a9c" providerId="ADAL" clId="{F518F96C-0279-4C88-9D30-7163CFBA3673}" dt="2023-09-26T08:38:24.318" v="26"/>
-        <pc:sldMkLst>
-          <pc:docMk/>
-          <pc:sldMk cId="3622438534" sldId="328"/>
-        </pc:sldMkLst>
-        <pc:picChg chg="del">
-          <ac:chgData name="Janusz Stal" userId="570fe9c4-9123-4bde-9755-2a9767a29a9c" providerId="ADAL" clId="{F518F96C-0279-4C88-9D30-7163CFBA3673}" dt="2023-09-22T12:40:47.708" v="7" actId="478"/>
-          <ac:picMkLst>
-            <pc:docMk/>
-            <pc:sldMk cId="3622438534" sldId="328"/>
-            <ac:picMk id="5" creationId="{1E3DAF72-D8A2-1049-DBBC-04C3268E1D55}"/>
-          </ac:picMkLst>
-        </pc:picChg>
-      </pc:sldChg>
-      <pc:sldChg chg="delSp mod modTransition delAnim">
-        <pc:chgData name="Janusz Stal" userId="570fe9c4-9123-4bde-9755-2a9767a29a9c" providerId="ADAL" clId="{F518F96C-0279-4C88-9D30-7163CFBA3673}" dt="2023-09-26T08:38:24.318" v="26"/>
-        <pc:sldMkLst>
-          <pc:docMk/>
-          <pc:sldMk cId="4232419462" sldId="329"/>
-        </pc:sldMkLst>
-        <pc:picChg chg="del">
-          <ac:chgData name="Janusz Stal" userId="570fe9c4-9123-4bde-9755-2a9767a29a9c" providerId="ADAL" clId="{F518F96C-0279-4C88-9D30-7163CFBA3673}" dt="2023-09-22T12:40:49.321" v="8" actId="478"/>
-          <ac:picMkLst>
-            <pc:docMk/>
-            <pc:sldMk cId="4232419462" sldId="329"/>
-            <ac:picMk id="2" creationId="{C5CFCB74-B6BA-E2AD-7251-F4FE72ACB48C}"/>
-          </ac:picMkLst>
-        </pc:picChg>
-      </pc:sldChg>
-      <pc:sldChg chg="delSp mod modTransition delAnim modNotesTx">
-        <pc:chgData name="Janusz Stal" userId="570fe9c4-9123-4bde-9755-2a9767a29a9c" providerId="ADAL" clId="{F518F96C-0279-4C88-9D30-7163CFBA3673}" dt="2023-09-29T09:10:54.755" v="131"/>
-        <pc:sldMkLst>
-          <pc:docMk/>
-          <pc:sldMk cId="322425298" sldId="330"/>
-        </pc:sldMkLst>
-        <pc:picChg chg="del">
-          <ac:chgData name="Janusz Stal" userId="570fe9c4-9123-4bde-9755-2a9767a29a9c" providerId="ADAL" clId="{F518F96C-0279-4C88-9D30-7163CFBA3673}" dt="2023-09-22T12:40:52.619" v="10" actId="478"/>
-          <ac:picMkLst>
-            <pc:docMk/>
-            <pc:sldMk cId="322425298" sldId="330"/>
-            <ac:picMk id="5" creationId="{7E2B0DB6-A417-5BAF-EAF7-F8E86F4467B0}"/>
-          </ac:picMkLst>
-        </pc:picChg>
-      </pc:sldChg>
-      <pc:sldChg chg="delSp mod modTransition delAnim modNotesTx">
-        <pc:chgData name="Janusz Stal" userId="570fe9c4-9123-4bde-9755-2a9767a29a9c" providerId="ADAL" clId="{F518F96C-0279-4C88-9D30-7163CFBA3673}" dt="2023-09-29T09:09:37.951" v="130" actId="20577"/>
-        <pc:sldMkLst>
-          <pc:docMk/>
-          <pc:sldMk cId="1840778044" sldId="332"/>
-        </pc:sldMkLst>
-        <pc:picChg chg="del">
-          <ac:chgData name="Janusz Stal" userId="570fe9c4-9123-4bde-9755-2a9767a29a9c" providerId="ADAL" clId="{F518F96C-0279-4C88-9D30-7163CFBA3673}" dt="2023-09-22T12:40:50.944" v="9" actId="478"/>
-          <ac:picMkLst>
-            <pc:docMk/>
-            <pc:sldMk cId="1840778044" sldId="332"/>
-            <ac:picMk id="2" creationId="{FABDC59A-1B21-E614-7A85-DDF163DE975F}"/>
-          </ac:picMkLst>
-        </pc:picChg>
-      </pc:sldChg>
-      <pc:sldChg chg="delSp mod modTransition delAnim modNotesTx">
-        <pc:chgData name="Janusz Stal" userId="570fe9c4-9123-4bde-9755-2a9767a29a9c" providerId="ADAL" clId="{F518F96C-0279-4C88-9D30-7163CFBA3673}" dt="2023-09-29T09:17:12.834" v="189" actId="20577"/>
-        <pc:sldMkLst>
-          <pc:docMk/>
-          <pc:sldMk cId="3714800936" sldId="333"/>
-        </pc:sldMkLst>
-        <pc:picChg chg="del">
-          <ac:chgData name="Janusz Stal" userId="570fe9c4-9123-4bde-9755-2a9767a29a9c" providerId="ADAL" clId="{F518F96C-0279-4C88-9D30-7163CFBA3673}" dt="2023-09-22T12:41:06.934" v="19" actId="478"/>
-          <ac:picMkLst>
-            <pc:docMk/>
-            <pc:sldMk cId="3714800936" sldId="333"/>
-            <ac:picMk id="5" creationId="{73373C7B-0DC0-9B21-F5B7-BDEE3E235DBC}"/>
-          </ac:picMkLst>
-        </pc:picChg>
-      </pc:sldChg>
-      <pc:sldChg chg="delSp mod modTransition delAnim modNotesTx">
-        <pc:chgData name="Janusz Stal" userId="570fe9c4-9123-4bde-9755-2a9767a29a9c" providerId="ADAL" clId="{F518F96C-0279-4C88-9D30-7163CFBA3673}" dt="2023-09-29T09:17:27.018" v="191" actId="20577"/>
-        <pc:sldMkLst>
-          <pc:docMk/>
-          <pc:sldMk cId="2277860244" sldId="334"/>
-        </pc:sldMkLst>
-        <pc:picChg chg="del">
-          <ac:chgData name="Janusz Stal" userId="570fe9c4-9123-4bde-9755-2a9767a29a9c" providerId="ADAL" clId="{F518F96C-0279-4C88-9D30-7163CFBA3673}" dt="2023-09-22T12:41:08.465" v="20" actId="478"/>
-          <ac:picMkLst>
-            <pc:docMk/>
-            <pc:sldMk cId="2277860244" sldId="334"/>
-            <ac:picMk id="5" creationId="{B08592C9-0B31-B84D-3A14-BA2C9DDFD4F0}"/>
-          </ac:picMkLst>
-        </pc:picChg>
-      </pc:sldChg>
-      <pc:sldChg chg="delSp mod modTransition delAnim modNotesTx">
-        <pc:chgData name="Janusz Stal" userId="570fe9c4-9123-4bde-9755-2a9767a29a9c" providerId="ADAL" clId="{F518F96C-0279-4C88-9D30-7163CFBA3673}" dt="2023-09-29T09:16:33.557" v="180" actId="6549"/>
-        <pc:sldMkLst>
-          <pc:docMk/>
-          <pc:sldMk cId="2173447150" sldId="335"/>
-        </pc:sldMkLst>
-        <pc:picChg chg="del">
-          <ac:chgData name="Janusz Stal" userId="570fe9c4-9123-4bde-9755-2a9767a29a9c" providerId="ADAL" clId="{F518F96C-0279-4C88-9D30-7163CFBA3673}" dt="2023-09-22T12:41:05.263" v="18" actId="478"/>
-          <ac:picMkLst>
-            <pc:docMk/>
-            <pc:sldMk cId="2173447150" sldId="335"/>
-            <ac:picMk id="5" creationId="{28F86802-566C-4094-A9B5-BEC4B029B77D}"/>
-          </ac:picMkLst>
-        </pc:picChg>
-      </pc:sldChg>
-      <pc:sldChg chg="delSp mod modTransition delAnim modNotesTx">
-        <pc:chgData name="Janusz Stal" userId="570fe9c4-9123-4bde-9755-2a9767a29a9c" providerId="ADAL" clId="{F518F96C-0279-4C88-9D30-7163CFBA3673}" dt="2023-09-29T09:18:43.118" v="203" actId="20577"/>
-        <pc:sldMkLst>
-          <pc:docMk/>
-          <pc:sldMk cId="3123027594" sldId="336"/>
-        </pc:sldMkLst>
-        <pc:picChg chg="del">
-          <ac:chgData name="Janusz Stal" userId="570fe9c4-9123-4bde-9755-2a9767a29a9c" providerId="ADAL" clId="{F518F96C-0279-4C88-9D30-7163CFBA3673}" dt="2023-09-22T12:41:12.155" v="22" actId="478"/>
-          <ac:picMkLst>
-            <pc:docMk/>
-            <pc:sldMk cId="3123027594" sldId="336"/>
-            <ac:picMk id="5" creationId="{4EAC2F37-E360-C7AA-5A95-B88CABE1E961}"/>
-          </ac:picMkLst>
-        </pc:picChg>
-      </pc:sldChg>
-      <pc:sldChg chg="delSp mod modTransition delAnim modNotesTx">
-        <pc:chgData name="Janusz Stal" userId="570fe9c4-9123-4bde-9755-2a9767a29a9c" providerId="ADAL" clId="{F518F96C-0279-4C88-9D30-7163CFBA3673}" dt="2023-09-29T09:17:55.160" v="192" actId="20577"/>
-        <pc:sldMkLst>
-          <pc:docMk/>
-          <pc:sldMk cId="3617956429" sldId="337"/>
-        </pc:sldMkLst>
-        <pc:picChg chg="del">
-          <ac:chgData name="Janusz Stal" userId="570fe9c4-9123-4bde-9755-2a9767a29a9c" providerId="ADAL" clId="{F518F96C-0279-4C88-9D30-7163CFBA3673}" dt="2023-09-22T12:41:10.125" v="21" actId="478"/>
-          <ac:picMkLst>
-            <pc:docMk/>
-            <pc:sldMk cId="3617956429" sldId="337"/>
-            <ac:picMk id="5" creationId="{96B9B7B3-E8FB-E744-97C0-5064E6E16B36}"/>
-          </ac:picMkLst>
-        </pc:picChg>
-      </pc:sldChg>
-      <pc:sldChg chg="delSp mod modTransition delAnim modNotesTx">
-        <pc:chgData name="Janusz Stal" userId="570fe9c4-9123-4bde-9755-2a9767a29a9c" providerId="ADAL" clId="{F518F96C-0279-4C88-9D30-7163CFBA3673}" dt="2023-09-29T09:19:24.792" v="206" actId="20577"/>
-        <pc:sldMkLst>
-          <pc:docMk/>
-          <pc:sldMk cId="1809690938" sldId="340"/>
-        </pc:sldMkLst>
-        <pc:picChg chg="del">
-          <ac:chgData name="Janusz Stal" userId="570fe9c4-9123-4bde-9755-2a9767a29a9c" providerId="ADAL" clId="{F518F96C-0279-4C88-9D30-7163CFBA3673}" dt="2023-09-22T12:41:15.429" v="24" actId="478"/>
-          <ac:picMkLst>
-            <pc:docMk/>
-            <pc:sldMk cId="1809690938" sldId="340"/>
-            <ac:picMk id="5" creationId="{1A16C401-54CE-CE97-BD66-73C2BC07F670}"/>
-          </ac:picMkLst>
-        </pc:picChg>
-      </pc:sldChg>
-      <pc:sldChg chg="delSp mod modTransition delAnim modNotesTx">
-        <pc:chgData name="Janusz Stal" userId="570fe9c4-9123-4bde-9755-2a9767a29a9c" providerId="ADAL" clId="{F518F96C-0279-4C88-9D30-7163CFBA3673}" dt="2023-09-29T09:20:41.232" v="207"/>
-        <pc:sldMkLst>
-          <pc:docMk/>
-          <pc:sldMk cId="125244385" sldId="341"/>
-        </pc:sldMkLst>
-        <pc:picChg chg="del">
-          <ac:chgData name="Janusz Stal" userId="570fe9c4-9123-4bde-9755-2a9767a29a9c" providerId="ADAL" clId="{F518F96C-0279-4C88-9D30-7163CFBA3673}" dt="2023-09-22T12:41:16.922" v="25" actId="478"/>
-          <ac:picMkLst>
-            <pc:docMk/>
-            <pc:sldMk cId="125244385" sldId="341"/>
-            <ac:picMk id="5" creationId="{793FF7EC-1353-F27F-8F02-5E0EC9986A04}"/>
-          </ac:picMkLst>
-        </pc:picChg>
-      </pc:sldChg>
-      <pc:sldChg chg="delSp modSp mod modTransition delAnim modNotesTx">
-        <pc:chgData name="Janusz Stal" userId="570fe9c4-9123-4bde-9755-2a9767a29a9c" providerId="ADAL" clId="{F518F96C-0279-4C88-9D30-7163CFBA3673}" dt="2023-09-29T09:05:57.687" v="87" actId="20577"/>
-        <pc:sldMkLst>
-          <pc:docMk/>
-          <pc:sldMk cId="3170683099" sldId="342"/>
-        </pc:sldMkLst>
-        <pc:spChg chg="mod">
-          <ac:chgData name="Janusz Stal" userId="570fe9c4-9123-4bde-9755-2a9767a29a9c" providerId="ADAL" clId="{F518F96C-0279-4C88-9D30-7163CFBA3673}" dt="2023-09-29T09:05:30.002" v="75" actId="20577"/>
-          <ac:spMkLst>
-            <pc:docMk/>
-            <pc:sldMk cId="3170683099" sldId="342"/>
-            <ac:spMk id="2" creationId="{323C843C-BB9F-F359-A3C4-389BFAB44E17}"/>
-          </ac:spMkLst>
-        </pc:spChg>
-        <pc:picChg chg="del">
-          <ac:chgData name="Janusz Stal" userId="570fe9c4-9123-4bde-9755-2a9767a29a9c" providerId="ADAL" clId="{F518F96C-0279-4C88-9D30-7163CFBA3673}" dt="2023-09-22T12:40:44.256" v="5" actId="478"/>
-          <ac:picMkLst>
-            <pc:docMk/>
-            <pc:sldMk cId="3170683099" sldId="342"/>
-            <ac:picMk id="5" creationId="{0602C7F8-5B87-07AF-85B4-0E6D14C811E1}"/>
-          </ac:picMkLst>
-        </pc:picChg>
-      </pc:sldChg>
-    </pc:docChg>
-  </pc:docChgLst>
-  <pc:docChgLst>
-    <pc:chgData name="Janusz Stal" userId="570fe9c4-9123-4bde-9755-2a9767a29a9c" providerId="ADAL" clId="{23EEAE0B-FDAB-46BF-B073-53A3CB61A1BE}"/>
-    <pc:docChg chg="undo custSel addSld delSld modSld sldOrd">
-      <pc:chgData name="Janusz Stal" userId="570fe9c4-9123-4bde-9755-2a9767a29a9c" providerId="ADAL" clId="{23EEAE0B-FDAB-46BF-B073-53A3CB61A1BE}" dt="2024-09-30T08:48:46.923" v="432" actId="20577"/>
-      <pc:docMkLst>
-        <pc:docMk/>
-      </pc:docMkLst>
-      <pc:sldChg chg="delSp modSp mod delAnim modNotesTx">
-        <pc:chgData name="Janusz Stal" userId="570fe9c4-9123-4bde-9755-2a9767a29a9c" providerId="ADAL" clId="{23EEAE0B-FDAB-46BF-B073-53A3CB61A1BE}" dt="2024-09-17T12:22:11.312" v="183" actId="6549"/>
+      <pc:sldChg chg="modSp mod">
+        <pc:chgData name="Janusz Stal" userId="570fe9c4-9123-4bde-9755-2a9767a29a9c" providerId="ADAL" clId="{93B0BD34-580E-4F7F-A301-D1F6EE30DB68}" dt="2026-10-03T15:38:43.472" v="41" actId="6549"/>
         <pc:sldMkLst>
           <pc:docMk/>
           <pc:sldMk cId="748555187" sldId="256"/>
         </pc:sldMkLst>
         <pc:spChg chg="mod">
-          <ac:chgData name="Janusz Stal" userId="570fe9c4-9123-4bde-9755-2a9767a29a9c" providerId="ADAL" clId="{23EEAE0B-FDAB-46BF-B073-53A3CB61A1BE}" dt="2024-09-17T11:53:17.325" v="38" actId="6549"/>
+          <ac:chgData name="Janusz Stal" userId="570fe9c4-9123-4bde-9755-2a9767a29a9c" providerId="ADAL" clId="{93B0BD34-580E-4F7F-A301-D1F6EE30DB68}" dt="2026-10-03T15:38:33.748" v="40" actId="20577"/>
           <ac:spMkLst>
             <pc:docMk/>
             <pc:sldMk cId="748555187" sldId="256"/>
@@ -577,705 +169,46 @@
           </ac:spMkLst>
         </pc:spChg>
         <pc:spChg chg="mod">
-          <ac:chgData name="Janusz Stal" userId="570fe9c4-9123-4bde-9755-2a9767a29a9c" providerId="ADAL" clId="{23EEAE0B-FDAB-46BF-B073-53A3CB61A1BE}" dt="2024-09-17T11:53:30.045" v="48" actId="20577"/>
+          <ac:chgData name="Janusz Stal" userId="570fe9c4-9123-4bde-9755-2a9767a29a9c" providerId="ADAL" clId="{93B0BD34-580E-4F7F-A301-D1F6EE30DB68}" dt="2026-10-03T15:38:43.472" v="41" actId="6549"/>
           <ac:spMkLst>
             <pc:docMk/>
             <pc:sldMk cId="748555187" sldId="256"/>
             <ac:spMk id="3" creationId="{00000000-0000-0000-0000-000000000000}"/>
           </ac:spMkLst>
         </pc:spChg>
-        <pc:picChg chg="del">
-          <ac:chgData name="Janusz Stal" userId="570fe9c4-9123-4bde-9755-2a9767a29a9c" providerId="ADAL" clId="{23EEAE0B-FDAB-46BF-B073-53A3CB61A1BE}" dt="2024-09-17T11:51:23.172" v="0" actId="478"/>
-          <ac:picMkLst>
-            <pc:docMk/>
-            <pc:sldMk cId="748555187" sldId="256"/>
-            <ac:picMk id="6" creationId="{B3CA5E3C-1DA1-D4D8-BF4D-D30FF3A62C45}"/>
-          </ac:picMkLst>
-        </pc:picChg>
       </pc:sldChg>
-      <pc:sldChg chg="delSp modSp mod ord delAnim modNotesTx">
-        <pc:chgData name="Janusz Stal" userId="570fe9c4-9123-4bde-9755-2a9767a29a9c" providerId="ADAL" clId="{23EEAE0B-FDAB-46BF-B073-53A3CB61A1BE}" dt="2024-09-17T12:30:24.689" v="287" actId="20577"/>
-        <pc:sldMkLst>
-          <pc:docMk/>
-          <pc:sldMk cId="3207883656" sldId="291"/>
-        </pc:sldMkLst>
-        <pc:spChg chg="mod">
-          <ac:chgData name="Janusz Stal" userId="570fe9c4-9123-4bde-9755-2a9767a29a9c" providerId="ADAL" clId="{23EEAE0B-FDAB-46BF-B073-53A3CB61A1BE}" dt="2024-09-17T12:30:24.689" v="287" actId="20577"/>
-          <ac:spMkLst>
-            <pc:docMk/>
-            <pc:sldMk cId="3207883656" sldId="291"/>
-            <ac:spMk id="6" creationId="{3BEF4DD1-DF03-4BD7-972C-609EAA9D84FC}"/>
-          </ac:spMkLst>
-        </pc:spChg>
-        <pc:picChg chg="del">
-          <ac:chgData name="Janusz Stal" userId="570fe9c4-9123-4bde-9755-2a9767a29a9c" providerId="ADAL" clId="{23EEAE0B-FDAB-46BF-B073-53A3CB61A1BE}" dt="2024-09-17T11:51:43.394" v="13" actId="478"/>
-          <ac:picMkLst>
-            <pc:docMk/>
-            <pc:sldMk cId="3207883656" sldId="291"/>
-            <ac:picMk id="3" creationId="{D0157B84-F1B1-6F89-AC31-2E4A3C0224A6}"/>
-          </ac:picMkLst>
-        </pc:picChg>
-      </pc:sldChg>
-      <pc:sldChg chg="delSp modSp mod delAnim modNotesTx">
-        <pc:chgData name="Janusz Stal" userId="570fe9c4-9123-4bde-9755-2a9767a29a9c" providerId="ADAL" clId="{23EEAE0B-FDAB-46BF-B073-53A3CB61A1BE}" dt="2024-09-17T12:24:18.372" v="211" actId="20578"/>
+      <pc:sldChg chg="modSp mod">
+        <pc:chgData name="Janusz Stal" userId="570fe9c4-9123-4bde-9755-2a9767a29a9c" providerId="ADAL" clId="{93B0BD34-580E-4F7F-A301-D1F6EE30DB68}" dt="2026-10-03T16:32:54.294" v="65" actId="13926"/>
         <pc:sldMkLst>
           <pc:docMk/>
           <pc:sldMk cId="3285343587" sldId="292"/>
         </pc:sldMkLst>
         <pc:spChg chg="mod">
-          <ac:chgData name="Janusz Stal" userId="570fe9c4-9123-4bde-9755-2a9767a29a9c" providerId="ADAL" clId="{23EEAE0B-FDAB-46BF-B073-53A3CB61A1BE}" dt="2024-09-17T12:24:18.372" v="211" actId="20578"/>
+          <ac:chgData name="Janusz Stal" userId="570fe9c4-9123-4bde-9755-2a9767a29a9c" providerId="ADAL" clId="{93B0BD34-580E-4F7F-A301-D1F6EE30DB68}" dt="2026-10-03T16:32:54.294" v="65" actId="13926"/>
           <ac:spMkLst>
             <pc:docMk/>
             <pc:sldMk cId="3285343587" sldId="292"/>
             <ac:spMk id="2" creationId="{3EDFA272-3930-484B-991B-B3AB08924CB2}"/>
           </ac:spMkLst>
         </pc:spChg>
-        <pc:picChg chg="del">
-          <ac:chgData name="Janusz Stal" userId="570fe9c4-9123-4bde-9755-2a9767a29a9c" providerId="ADAL" clId="{23EEAE0B-FDAB-46BF-B073-53A3CB61A1BE}" dt="2024-09-17T11:51:26.074" v="1" actId="478"/>
-          <ac:picMkLst>
-            <pc:docMk/>
-            <pc:sldMk cId="3285343587" sldId="292"/>
-            <ac:picMk id="6" creationId="{0FEE95E6-909C-0D3C-5D17-819051D7CB4A}"/>
-          </ac:picMkLst>
-        </pc:picChg>
       </pc:sldChg>
-      <pc:sldChg chg="delSp modSp mod delAnim modNotesTx">
-        <pc:chgData name="Janusz Stal" userId="570fe9c4-9123-4bde-9755-2a9767a29a9c" providerId="ADAL" clId="{23EEAE0B-FDAB-46BF-B073-53A3CB61A1BE}" dt="2024-09-17T12:22:23.668" v="187" actId="6549"/>
-        <pc:sldMkLst>
-          <pc:docMk/>
-          <pc:sldMk cId="665344467" sldId="304"/>
-        </pc:sldMkLst>
-        <pc:graphicFrameChg chg="mod modGraphic">
-          <ac:chgData name="Janusz Stal" userId="570fe9c4-9123-4bde-9755-2a9767a29a9c" providerId="ADAL" clId="{23EEAE0B-FDAB-46BF-B073-53A3CB61A1BE}" dt="2024-09-17T12:21:35.072" v="182" actId="2165"/>
-          <ac:graphicFrameMkLst>
-            <pc:docMk/>
-            <pc:sldMk cId="665344467" sldId="304"/>
-            <ac:graphicFrameMk id="10" creationId="{F6C54067-57EB-4DCA-B29A-43AE2214302B}"/>
-          </ac:graphicFrameMkLst>
-        </pc:graphicFrameChg>
-        <pc:picChg chg="del">
-          <ac:chgData name="Janusz Stal" userId="570fe9c4-9123-4bde-9755-2a9767a29a9c" providerId="ADAL" clId="{23EEAE0B-FDAB-46BF-B073-53A3CB61A1BE}" dt="2024-09-17T11:51:31.076" v="4" actId="478"/>
-          <ac:picMkLst>
-            <pc:docMk/>
-            <pc:sldMk cId="665344467" sldId="304"/>
-            <ac:picMk id="3" creationId="{3D90171A-C570-E603-CCA8-EAAFC8DEA19D}"/>
-          </ac:picMkLst>
-        </pc:picChg>
-      </pc:sldChg>
-      <pc:sldChg chg="delSp mod delAnim modNotesTx">
-        <pc:chgData name="Janusz Stal" userId="570fe9c4-9123-4bde-9755-2a9767a29a9c" providerId="ADAL" clId="{23EEAE0B-FDAB-46BF-B073-53A3CB61A1BE}" dt="2024-09-17T12:22:21.257" v="186" actId="6549"/>
-        <pc:sldMkLst>
-          <pc:docMk/>
-          <pc:sldMk cId="995346915" sldId="306"/>
-        </pc:sldMkLst>
-        <pc:picChg chg="del">
-          <ac:chgData name="Janusz Stal" userId="570fe9c4-9123-4bde-9755-2a9767a29a9c" providerId="ADAL" clId="{23EEAE0B-FDAB-46BF-B073-53A3CB61A1BE}" dt="2024-09-17T11:51:29.695" v="3" actId="478"/>
-          <ac:picMkLst>
-            <pc:docMk/>
-            <pc:sldMk cId="995346915" sldId="306"/>
-            <ac:picMk id="6" creationId="{D05245F2-2393-EE62-3E04-6504CE4989C9}"/>
-          </ac:picMkLst>
-        </pc:picChg>
-      </pc:sldChg>
-      <pc:sldChg chg="delSp modSp mod delAnim modNotesTx">
-        <pc:chgData name="Janusz Stal" userId="570fe9c4-9123-4bde-9755-2a9767a29a9c" providerId="ADAL" clId="{23EEAE0B-FDAB-46BF-B073-53A3CB61A1BE}" dt="2024-09-17T12:22:28.402" v="189" actId="6549"/>
-        <pc:sldMkLst>
-          <pc:docMk/>
-          <pc:sldMk cId="481222839" sldId="307"/>
-        </pc:sldMkLst>
-        <pc:graphicFrameChg chg="modGraphic">
-          <ac:chgData name="Janusz Stal" userId="570fe9c4-9123-4bde-9755-2a9767a29a9c" providerId="ADAL" clId="{23EEAE0B-FDAB-46BF-B073-53A3CB61A1BE}" dt="2024-09-17T11:58:58.237" v="113" actId="20577"/>
-          <ac:graphicFrameMkLst>
-            <pc:docMk/>
-            <pc:sldMk cId="481222839" sldId="307"/>
-            <ac:graphicFrameMk id="7" creationId="{FDAE31E2-5969-4434-A806-67653374A219}"/>
-          </ac:graphicFrameMkLst>
-        </pc:graphicFrameChg>
-        <pc:picChg chg="del">
-          <ac:chgData name="Janusz Stal" userId="570fe9c4-9123-4bde-9755-2a9767a29a9c" providerId="ADAL" clId="{23EEAE0B-FDAB-46BF-B073-53A3CB61A1BE}" dt="2024-09-17T11:51:33.466" v="6" actId="478"/>
-          <ac:picMkLst>
-            <pc:docMk/>
-            <pc:sldMk cId="481222839" sldId="307"/>
-            <ac:picMk id="5" creationId="{542114A5-1A26-A912-80E5-DE4D9AA1B176}"/>
-          </ac:picMkLst>
-        </pc:picChg>
-      </pc:sldChg>
-      <pc:sldChg chg="delSp mod ord delAnim modNotesTx">
-        <pc:chgData name="Janusz Stal" userId="570fe9c4-9123-4bde-9755-2a9767a29a9c" providerId="ADAL" clId="{23EEAE0B-FDAB-46BF-B073-53A3CB61A1BE}" dt="2024-09-17T12:35:22.982" v="316"/>
-        <pc:sldMkLst>
-          <pc:docMk/>
-          <pc:sldMk cId="3376502272" sldId="312"/>
-        </pc:sldMkLst>
-        <pc:picChg chg="del">
-          <ac:chgData name="Janusz Stal" userId="570fe9c4-9123-4bde-9755-2a9767a29a9c" providerId="ADAL" clId="{23EEAE0B-FDAB-46BF-B073-53A3CB61A1BE}" dt="2024-09-17T11:51:40.386" v="11" actId="478"/>
-          <ac:picMkLst>
-            <pc:docMk/>
-            <pc:sldMk cId="3376502272" sldId="312"/>
-            <ac:picMk id="7" creationId="{7A640A32-32EA-9423-089F-671DCC04E977}"/>
-          </ac:picMkLst>
-        </pc:picChg>
-      </pc:sldChg>
-      <pc:sldChg chg="delSp modSp mod ord delAnim modNotesTx">
-        <pc:chgData name="Janusz Stal" userId="570fe9c4-9123-4bde-9755-2a9767a29a9c" providerId="ADAL" clId="{23EEAE0B-FDAB-46BF-B073-53A3CB61A1BE}" dt="2024-09-17T12:27:46.324" v="213"/>
+      <pc:sldChg chg="modSp mod">
+        <pc:chgData name="Janusz Stal" userId="570fe9c4-9123-4bde-9755-2a9767a29a9c" providerId="ADAL" clId="{93B0BD34-580E-4F7F-A301-D1F6EE30DB68}" dt="2026-10-03T16:34:16.774" v="98" actId="20577"/>
         <pc:sldMkLst>
           <pc:docMk/>
           <pc:sldMk cId="1144236073" sldId="316"/>
         </pc:sldMkLst>
         <pc:spChg chg="mod">
-          <ac:chgData name="Janusz Stal" userId="570fe9c4-9123-4bde-9755-2a9767a29a9c" providerId="ADAL" clId="{23EEAE0B-FDAB-46BF-B073-53A3CB61A1BE}" dt="2024-09-17T12:01:12.921" v="135" actId="20577"/>
+          <ac:chgData name="Janusz Stal" userId="570fe9c4-9123-4bde-9755-2a9767a29a9c" providerId="ADAL" clId="{93B0BD34-580E-4F7F-A301-D1F6EE30DB68}" dt="2026-10-03T16:34:16.774" v="98" actId="20577"/>
           <ac:spMkLst>
             <pc:docMk/>
             <pc:sldMk cId="1144236073" sldId="316"/>
             <ac:spMk id="2" creationId="{C7200191-8C7A-20BB-91B3-C7A0EB4D769B}"/>
           </ac:spMkLst>
         </pc:spChg>
-        <pc:picChg chg="del">
-          <ac:chgData name="Janusz Stal" userId="570fe9c4-9123-4bde-9755-2a9767a29a9c" providerId="ADAL" clId="{23EEAE0B-FDAB-46BF-B073-53A3CB61A1BE}" dt="2024-09-17T11:51:44.725" v="14" actId="478"/>
-          <ac:picMkLst>
-            <pc:docMk/>
-            <pc:sldMk cId="1144236073" sldId="316"/>
-            <ac:picMk id="6" creationId="{2B0B30B4-7CE9-56C8-C000-2B483623BEE5}"/>
-          </ac:picMkLst>
-        </pc:picChg>
       </pc:sldChg>
-      <pc:sldChg chg="delSp modSp mod ord delAnim modNotesTx">
-        <pc:chgData name="Janusz Stal" userId="570fe9c4-9123-4bde-9755-2a9767a29a9c" providerId="ADAL" clId="{23EEAE0B-FDAB-46BF-B073-53A3CB61A1BE}" dt="2024-09-17T12:31:47.526" v="302" actId="20577"/>
-        <pc:sldMkLst>
-          <pc:docMk/>
-          <pc:sldMk cId="2533284800" sldId="317"/>
-        </pc:sldMkLst>
-        <pc:spChg chg="mod">
-          <ac:chgData name="Janusz Stal" userId="570fe9c4-9123-4bde-9755-2a9767a29a9c" providerId="ADAL" clId="{23EEAE0B-FDAB-46BF-B073-53A3CB61A1BE}" dt="2024-09-17T12:31:47.526" v="302" actId="20577"/>
-          <ac:spMkLst>
-            <pc:docMk/>
-            <pc:sldMk cId="2533284800" sldId="317"/>
-            <ac:spMk id="2" creationId="{27533B2D-CAC7-E97B-7182-1838AAEFBF00}"/>
-          </ac:spMkLst>
-        </pc:spChg>
-        <pc:picChg chg="del">
-          <ac:chgData name="Janusz Stal" userId="570fe9c4-9123-4bde-9755-2a9767a29a9c" providerId="ADAL" clId="{23EEAE0B-FDAB-46BF-B073-53A3CB61A1BE}" dt="2024-09-17T11:51:45.983" v="15" actId="478"/>
-          <ac:picMkLst>
-            <pc:docMk/>
-            <pc:sldMk cId="2533284800" sldId="317"/>
-            <ac:picMk id="6" creationId="{72433736-755F-8691-57D8-AEB571E082C4}"/>
-          </ac:picMkLst>
-        </pc:picChg>
-      </pc:sldChg>
-      <pc:sldChg chg="delSp modSp mod ord delAnim modNotesTx">
-        <pc:chgData name="Janusz Stal" userId="570fe9c4-9123-4bde-9755-2a9767a29a9c" providerId="ADAL" clId="{23EEAE0B-FDAB-46BF-B073-53A3CB61A1BE}" dt="2024-09-17T12:27:46.324" v="213"/>
-        <pc:sldMkLst>
-          <pc:docMk/>
-          <pc:sldMk cId="1234291028" sldId="318"/>
-        </pc:sldMkLst>
-        <pc:spChg chg="mod">
-          <ac:chgData name="Janusz Stal" userId="570fe9c4-9123-4bde-9755-2a9767a29a9c" providerId="ADAL" clId="{23EEAE0B-FDAB-46BF-B073-53A3CB61A1BE}" dt="2024-09-17T12:03:01.782" v="170" actId="20577"/>
-          <ac:spMkLst>
-            <pc:docMk/>
-            <pc:sldMk cId="1234291028" sldId="318"/>
-            <ac:spMk id="2" creationId="{D53BE413-5EBF-69E5-69B0-2BCC40EBBB43}"/>
-          </ac:spMkLst>
-        </pc:spChg>
-        <pc:picChg chg="del">
-          <ac:chgData name="Janusz Stal" userId="570fe9c4-9123-4bde-9755-2a9767a29a9c" providerId="ADAL" clId="{23EEAE0B-FDAB-46BF-B073-53A3CB61A1BE}" dt="2024-09-17T11:51:47.322" v="16" actId="478"/>
-          <ac:picMkLst>
-            <pc:docMk/>
-            <pc:sldMk cId="1234291028" sldId="318"/>
-            <ac:picMk id="6" creationId="{C45C8ABF-DC0E-A0B3-4A60-D452DE29DB29}"/>
-          </ac:picMkLst>
-        </pc:picChg>
-      </pc:sldChg>
-      <pc:sldChg chg="delSp mod delAnim modNotesTx">
-        <pc:chgData name="Janusz Stal" userId="570fe9c4-9123-4bde-9755-2a9767a29a9c" providerId="ADAL" clId="{23EEAE0B-FDAB-46BF-B073-53A3CB61A1BE}" dt="2024-09-17T12:22:54.367" v="200" actId="6549"/>
-        <pc:sldMkLst>
-          <pc:docMk/>
-          <pc:sldMk cId="3984066826" sldId="319"/>
-        </pc:sldMkLst>
-        <pc:picChg chg="del">
-          <ac:chgData name="Janusz Stal" userId="570fe9c4-9123-4bde-9755-2a9767a29a9c" providerId="ADAL" clId="{23EEAE0B-FDAB-46BF-B073-53A3CB61A1BE}" dt="2024-09-17T11:51:48.696" v="17" actId="478"/>
-          <ac:picMkLst>
-            <pc:docMk/>
-            <pc:sldMk cId="3984066826" sldId="319"/>
-            <ac:picMk id="6" creationId="{76773E07-0CA9-D22D-C9A2-546A4FFEB85D}"/>
-          </ac:picMkLst>
-        </pc:picChg>
-      </pc:sldChg>
-      <pc:sldChg chg="delSp modSp mod ord delAnim modNotesTx">
-        <pc:chgData name="Janusz Stal" userId="570fe9c4-9123-4bde-9755-2a9767a29a9c" providerId="ADAL" clId="{23EEAE0B-FDAB-46BF-B073-53A3CB61A1BE}" dt="2024-09-17T12:34:12.933" v="314" actId="113"/>
-        <pc:sldMkLst>
-          <pc:docMk/>
-          <pc:sldMk cId="1005848108" sldId="320"/>
-        </pc:sldMkLst>
-        <pc:spChg chg="mod">
-          <ac:chgData name="Janusz Stal" userId="570fe9c4-9123-4bde-9755-2a9767a29a9c" providerId="ADAL" clId="{23EEAE0B-FDAB-46BF-B073-53A3CB61A1BE}" dt="2024-09-17T12:34:01.383" v="311" actId="20577"/>
-          <ac:spMkLst>
-            <pc:docMk/>
-            <pc:sldMk cId="1005848108" sldId="320"/>
-            <ac:spMk id="2" creationId="{005DE35A-36F4-48CE-5B82-D9ABD47366FC}"/>
-          </ac:spMkLst>
-        </pc:spChg>
-        <pc:spChg chg="mod">
-          <ac:chgData name="Janusz Stal" userId="570fe9c4-9123-4bde-9755-2a9767a29a9c" providerId="ADAL" clId="{23EEAE0B-FDAB-46BF-B073-53A3CB61A1BE}" dt="2024-09-17T12:34:12.933" v="314" actId="113"/>
-          <ac:spMkLst>
-            <pc:docMk/>
-            <pc:sldMk cId="1005848108" sldId="320"/>
-            <ac:spMk id="3" creationId="{5C593541-A8CA-3595-EFED-636ACE762969}"/>
-          </ac:spMkLst>
-        </pc:spChg>
-        <pc:picChg chg="del">
-          <ac:chgData name="Janusz Stal" userId="570fe9c4-9123-4bde-9755-2a9767a29a9c" providerId="ADAL" clId="{23EEAE0B-FDAB-46BF-B073-53A3CB61A1BE}" dt="2024-09-17T11:51:41.853" v="12" actId="478"/>
-          <ac:picMkLst>
-            <pc:docMk/>
-            <pc:sldMk cId="1005848108" sldId="320"/>
-            <ac:picMk id="6" creationId="{3ABFFE52-E66E-0E95-CB09-06C8C0EBB0BC}"/>
-          </ac:picMkLst>
-        </pc:picChg>
-      </pc:sldChg>
-      <pc:sldChg chg="delSp mod delAnim modNotesTx">
-        <pc:chgData name="Janusz Stal" userId="570fe9c4-9123-4bde-9755-2a9767a29a9c" providerId="ADAL" clId="{23EEAE0B-FDAB-46BF-B073-53A3CB61A1BE}" dt="2024-09-17T12:23:16.096" v="206" actId="6549"/>
-        <pc:sldMkLst>
-          <pc:docMk/>
-          <pc:sldMk cId="2525688714" sldId="323"/>
-        </pc:sldMkLst>
-        <pc:picChg chg="del">
-          <ac:chgData name="Janusz Stal" userId="570fe9c4-9123-4bde-9755-2a9767a29a9c" providerId="ADAL" clId="{23EEAE0B-FDAB-46BF-B073-53A3CB61A1BE}" dt="2024-09-17T11:51:57.032" v="23" actId="478"/>
-          <ac:picMkLst>
-            <pc:docMk/>
-            <pc:sldMk cId="2525688714" sldId="323"/>
-            <ac:picMk id="6" creationId="{FE9B4AE8-9A37-1960-A126-2EDBE76A581D}"/>
-          </ac:picMkLst>
-        </pc:picChg>
-      </pc:sldChg>
-      <pc:sldChg chg="delSp mod delAnim modNotesTx">
-        <pc:chgData name="Janusz Stal" userId="570fe9c4-9123-4bde-9755-2a9767a29a9c" providerId="ADAL" clId="{23EEAE0B-FDAB-46BF-B073-53A3CB61A1BE}" dt="2024-09-17T12:22:18.891" v="185" actId="6549"/>
-        <pc:sldMkLst>
-          <pc:docMk/>
-          <pc:sldMk cId="2130001478" sldId="327"/>
-        </pc:sldMkLst>
-        <pc:picChg chg="del">
-          <ac:chgData name="Janusz Stal" userId="570fe9c4-9123-4bde-9755-2a9767a29a9c" providerId="ADAL" clId="{23EEAE0B-FDAB-46BF-B073-53A3CB61A1BE}" dt="2024-09-17T11:51:27.823" v="2" actId="478"/>
-          <ac:picMkLst>
-            <pc:docMk/>
-            <pc:sldMk cId="2130001478" sldId="327"/>
-            <ac:picMk id="6" creationId="{858535FF-A054-2549-E3AA-4F0E866CA4AE}"/>
-          </ac:picMkLst>
-        </pc:picChg>
-      </pc:sldChg>
-      <pc:sldChg chg="delSp del mod ord delAnim modNotesTx">
-        <pc:chgData name="Janusz Stal" userId="570fe9c4-9123-4bde-9755-2a9767a29a9c" providerId="ADAL" clId="{23EEAE0B-FDAB-46BF-B073-53A3CB61A1BE}" dt="2024-09-17T12:44:24.076" v="349" actId="47"/>
-        <pc:sldMkLst>
-          <pc:docMk/>
-          <pc:sldMk cId="3622438534" sldId="328"/>
-        </pc:sldMkLst>
-        <pc:picChg chg="del">
-          <ac:chgData name="Janusz Stal" userId="570fe9c4-9123-4bde-9755-2a9767a29a9c" providerId="ADAL" clId="{23EEAE0B-FDAB-46BF-B073-53A3CB61A1BE}" dt="2024-09-17T11:51:34.908" v="7" actId="478"/>
-          <ac:picMkLst>
-            <pc:docMk/>
-            <pc:sldMk cId="3622438534" sldId="328"/>
-            <ac:picMk id="6" creationId="{5E1B9550-5EE2-C4B4-3527-8D4F0DAD6B20}"/>
-          </ac:picMkLst>
-        </pc:picChg>
-      </pc:sldChg>
-      <pc:sldChg chg="delSp del mod ord delAnim modNotesTx">
-        <pc:chgData name="Janusz Stal" userId="570fe9c4-9123-4bde-9755-2a9767a29a9c" providerId="ADAL" clId="{23EEAE0B-FDAB-46BF-B073-53A3CB61A1BE}" dt="2024-09-17T12:44:24.076" v="349" actId="47"/>
-        <pc:sldMkLst>
-          <pc:docMk/>
-          <pc:sldMk cId="4232419462" sldId="329"/>
-        </pc:sldMkLst>
-        <pc:picChg chg="del">
-          <ac:chgData name="Janusz Stal" userId="570fe9c4-9123-4bde-9755-2a9767a29a9c" providerId="ADAL" clId="{23EEAE0B-FDAB-46BF-B073-53A3CB61A1BE}" dt="2024-09-17T11:51:36.358" v="8" actId="478"/>
-          <ac:picMkLst>
-            <pc:docMk/>
-            <pc:sldMk cId="4232419462" sldId="329"/>
-            <ac:picMk id="6" creationId="{6A359C81-8C19-E337-9644-E133179CC2CF}"/>
-          </ac:picMkLst>
-        </pc:picChg>
-      </pc:sldChg>
-      <pc:sldChg chg="delSp del mod ord delAnim modNotesTx">
-        <pc:chgData name="Janusz Stal" userId="570fe9c4-9123-4bde-9755-2a9767a29a9c" providerId="ADAL" clId="{23EEAE0B-FDAB-46BF-B073-53A3CB61A1BE}" dt="2024-09-17T12:36:43.516" v="323" actId="47"/>
-        <pc:sldMkLst>
-          <pc:docMk/>
-          <pc:sldMk cId="322425298" sldId="330"/>
-        </pc:sldMkLst>
-        <pc:picChg chg="del">
-          <ac:chgData name="Janusz Stal" userId="570fe9c4-9123-4bde-9755-2a9767a29a9c" providerId="ADAL" clId="{23EEAE0B-FDAB-46BF-B073-53A3CB61A1BE}" dt="2024-09-17T11:51:39.127" v="10" actId="478"/>
-          <ac:picMkLst>
-            <pc:docMk/>
-            <pc:sldMk cId="322425298" sldId="330"/>
-            <ac:picMk id="6" creationId="{81C409E9-9993-12CC-61D5-CAEE9339B6DC}"/>
-          </ac:picMkLst>
-        </pc:picChg>
-      </pc:sldChg>
-      <pc:sldChg chg="delSp del mod ord delAnim modNotesTx">
-        <pc:chgData name="Janusz Stal" userId="570fe9c4-9123-4bde-9755-2a9767a29a9c" providerId="ADAL" clId="{23EEAE0B-FDAB-46BF-B073-53A3CB61A1BE}" dt="2024-09-17T12:39:04.631" v="327" actId="47"/>
-        <pc:sldMkLst>
-          <pc:docMk/>
-          <pc:sldMk cId="1840778044" sldId="332"/>
-        </pc:sldMkLst>
-        <pc:picChg chg="del">
-          <ac:chgData name="Janusz Stal" userId="570fe9c4-9123-4bde-9755-2a9767a29a9c" providerId="ADAL" clId="{23EEAE0B-FDAB-46BF-B073-53A3CB61A1BE}" dt="2024-09-17T11:51:37.884" v="9" actId="478"/>
-          <ac:picMkLst>
-            <pc:docMk/>
-            <pc:sldMk cId="1840778044" sldId="332"/>
-            <ac:picMk id="5" creationId="{FF1EBE97-8DA0-0BD0-DAA6-5BEBB5956A5E}"/>
-          </ac:picMkLst>
-        </pc:picChg>
-      </pc:sldChg>
-      <pc:sldChg chg="delSp mod ord delAnim modNotesTx">
-        <pc:chgData name="Janusz Stal" userId="570fe9c4-9123-4bde-9755-2a9767a29a9c" providerId="ADAL" clId="{23EEAE0B-FDAB-46BF-B073-53A3CB61A1BE}" dt="2024-09-17T12:36:00.383" v="318"/>
-        <pc:sldMkLst>
-          <pc:docMk/>
-          <pc:sldMk cId="3714800936" sldId="333"/>
-        </pc:sldMkLst>
-        <pc:picChg chg="del">
-          <ac:chgData name="Janusz Stal" userId="570fe9c4-9123-4bde-9755-2a9767a29a9c" providerId="ADAL" clId="{23EEAE0B-FDAB-46BF-B073-53A3CB61A1BE}" dt="2024-09-17T11:51:51.138" v="19" actId="478"/>
-          <ac:picMkLst>
-            <pc:docMk/>
-            <pc:sldMk cId="3714800936" sldId="333"/>
-            <ac:picMk id="6" creationId="{E91F1515-6C44-8961-4558-3B78E615C823}"/>
-          </ac:picMkLst>
-        </pc:picChg>
-      </pc:sldChg>
-      <pc:sldChg chg="addSp delSp modSp mod ord delAnim modNotesTx">
-        <pc:chgData name="Janusz Stal" userId="570fe9c4-9123-4bde-9755-2a9767a29a9c" providerId="ADAL" clId="{23EEAE0B-FDAB-46BF-B073-53A3CB61A1BE}" dt="2024-09-17T12:42:44.154" v="348" actId="207"/>
-        <pc:sldMkLst>
-          <pc:docMk/>
-          <pc:sldMk cId="2277860244" sldId="334"/>
-        </pc:sldMkLst>
-        <pc:spChg chg="mod">
-          <ac:chgData name="Janusz Stal" userId="570fe9c4-9123-4bde-9755-2a9767a29a9c" providerId="ADAL" clId="{23EEAE0B-FDAB-46BF-B073-53A3CB61A1BE}" dt="2024-09-17T12:42:44.154" v="348" actId="207"/>
-          <ac:spMkLst>
-            <pc:docMk/>
-            <pc:sldMk cId="2277860244" sldId="334"/>
-            <ac:spMk id="2" creationId="{022B2B4D-12C6-7E2E-9BAD-A158F0EBE445}"/>
-          </ac:spMkLst>
-        </pc:spChg>
-        <pc:picChg chg="add mod">
-          <ac:chgData name="Janusz Stal" userId="570fe9c4-9123-4bde-9755-2a9767a29a9c" providerId="ADAL" clId="{23EEAE0B-FDAB-46BF-B073-53A3CB61A1BE}" dt="2024-09-17T12:39:20.716" v="329" actId="1076"/>
-          <ac:picMkLst>
-            <pc:docMk/>
-            <pc:sldMk cId="2277860244" sldId="334"/>
-            <ac:picMk id="5" creationId="{64E73868-FA0F-3C85-8433-E6271702437B}"/>
-          </ac:picMkLst>
-        </pc:picChg>
-        <pc:picChg chg="del">
-          <ac:chgData name="Janusz Stal" userId="570fe9c4-9123-4bde-9755-2a9767a29a9c" providerId="ADAL" clId="{23EEAE0B-FDAB-46BF-B073-53A3CB61A1BE}" dt="2024-09-17T11:51:52.570" v="20" actId="478"/>
-          <ac:picMkLst>
-            <pc:docMk/>
-            <pc:sldMk cId="2277860244" sldId="334"/>
-            <ac:picMk id="6" creationId="{890C7081-D76E-0C0A-D691-EFD88810A68F}"/>
-          </ac:picMkLst>
-        </pc:picChg>
-      </pc:sldChg>
-      <pc:sldChg chg="delSp mod ord delAnim modNotesTx">
-        <pc:chgData name="Janusz Stal" userId="570fe9c4-9123-4bde-9755-2a9767a29a9c" providerId="ADAL" clId="{23EEAE0B-FDAB-46BF-B073-53A3CB61A1BE}" dt="2024-09-17T12:41:48.707" v="344"/>
-        <pc:sldMkLst>
-          <pc:docMk/>
-          <pc:sldMk cId="2173447150" sldId="335"/>
-        </pc:sldMkLst>
-        <pc:picChg chg="del">
-          <ac:chgData name="Janusz Stal" userId="570fe9c4-9123-4bde-9755-2a9767a29a9c" providerId="ADAL" clId="{23EEAE0B-FDAB-46BF-B073-53A3CB61A1BE}" dt="2024-09-17T11:51:49.943" v="18" actId="478"/>
-          <ac:picMkLst>
-            <pc:docMk/>
-            <pc:sldMk cId="2173447150" sldId="335"/>
-            <ac:picMk id="6" creationId="{5BEC2709-30E7-378C-A909-BE890C503E78}"/>
-          </ac:picMkLst>
-        </pc:picChg>
-      </pc:sldChg>
-      <pc:sldChg chg="delSp del mod delAnim modNotesTx">
-        <pc:chgData name="Janusz Stal" userId="570fe9c4-9123-4bde-9755-2a9767a29a9c" providerId="ADAL" clId="{23EEAE0B-FDAB-46BF-B073-53A3CB61A1BE}" dt="2024-09-17T12:37:45.472" v="324" actId="47"/>
-        <pc:sldMkLst>
-          <pc:docMk/>
-          <pc:sldMk cId="3123027594" sldId="336"/>
-        </pc:sldMkLst>
-        <pc:picChg chg="del">
-          <ac:chgData name="Janusz Stal" userId="570fe9c4-9123-4bde-9755-2a9767a29a9c" providerId="ADAL" clId="{23EEAE0B-FDAB-46BF-B073-53A3CB61A1BE}" dt="2024-09-17T11:51:55.602" v="22" actId="478"/>
-          <ac:picMkLst>
-            <pc:docMk/>
-            <pc:sldMk cId="3123027594" sldId="336"/>
-            <ac:picMk id="6" creationId="{DA080BEA-3AED-2361-057D-3E077997A1BD}"/>
-          </ac:picMkLst>
-        </pc:picChg>
-      </pc:sldChg>
-      <pc:sldChg chg="addSp delSp modSp mod ord delAnim modNotesTx">
-        <pc:chgData name="Janusz Stal" userId="570fe9c4-9123-4bde-9755-2a9767a29a9c" providerId="ADAL" clId="{23EEAE0B-FDAB-46BF-B073-53A3CB61A1BE}" dt="2024-09-17T12:41:35.681" v="342" actId="1076"/>
-        <pc:sldMkLst>
-          <pc:docMk/>
-          <pc:sldMk cId="3617956429" sldId="337"/>
-        </pc:sldMkLst>
-        <pc:picChg chg="add mod">
-          <ac:chgData name="Janusz Stal" userId="570fe9c4-9123-4bde-9755-2a9767a29a9c" providerId="ADAL" clId="{23EEAE0B-FDAB-46BF-B073-53A3CB61A1BE}" dt="2024-09-17T12:41:35.681" v="342" actId="1076"/>
-          <ac:picMkLst>
-            <pc:docMk/>
-            <pc:sldMk cId="3617956429" sldId="337"/>
-            <ac:picMk id="5" creationId="{390D1807-6EF0-E7CE-38C6-82B3012FA1FA}"/>
-          </ac:picMkLst>
-        </pc:picChg>
-        <pc:picChg chg="del">
-          <ac:chgData name="Janusz Stal" userId="570fe9c4-9123-4bde-9755-2a9767a29a9c" providerId="ADAL" clId="{23EEAE0B-FDAB-46BF-B073-53A3CB61A1BE}" dt="2024-09-17T11:51:54.141" v="21" actId="478"/>
-          <ac:picMkLst>
-            <pc:docMk/>
-            <pc:sldMk cId="3617956429" sldId="337"/>
-            <ac:picMk id="7" creationId="{AC30D770-7546-1CA4-3839-83D0825EDD41}"/>
-          </ac:picMkLst>
-        </pc:picChg>
-      </pc:sldChg>
-      <pc:sldChg chg="delSp modSp mod delAnim modNotesTx">
-        <pc:chgData name="Janusz Stal" userId="570fe9c4-9123-4bde-9755-2a9767a29a9c" providerId="ADAL" clId="{23EEAE0B-FDAB-46BF-B073-53A3CB61A1BE}" dt="2024-09-17T12:23:18.192" v="207" actId="6549"/>
-        <pc:sldMkLst>
-          <pc:docMk/>
-          <pc:sldMk cId="1809690938" sldId="340"/>
-        </pc:sldMkLst>
-        <pc:spChg chg="mod">
-          <ac:chgData name="Janusz Stal" userId="570fe9c4-9123-4bde-9755-2a9767a29a9c" providerId="ADAL" clId="{23EEAE0B-FDAB-46BF-B073-53A3CB61A1BE}" dt="2024-09-17T12:07:48.437" v="174" actId="20577"/>
-          <ac:spMkLst>
-            <pc:docMk/>
-            <pc:sldMk cId="1809690938" sldId="340"/>
-            <ac:spMk id="2" creationId="{F9B3077B-F8DD-C67E-9F11-D4182C72C97A}"/>
-          </ac:spMkLst>
-        </pc:spChg>
-        <pc:picChg chg="del">
-          <ac:chgData name="Janusz Stal" userId="570fe9c4-9123-4bde-9755-2a9767a29a9c" providerId="ADAL" clId="{23EEAE0B-FDAB-46BF-B073-53A3CB61A1BE}" dt="2024-09-17T11:51:58.400" v="24" actId="478"/>
-          <ac:picMkLst>
-            <pc:docMk/>
-            <pc:sldMk cId="1809690938" sldId="340"/>
-            <ac:picMk id="6" creationId="{23FC0E14-DD36-6E11-CE4A-1ADA4A71FF36}"/>
-          </ac:picMkLst>
-        </pc:picChg>
-      </pc:sldChg>
-      <pc:sldChg chg="delSp del mod delAnim modNotesTx">
-        <pc:chgData name="Janusz Stal" userId="570fe9c4-9123-4bde-9755-2a9767a29a9c" providerId="ADAL" clId="{23EEAE0B-FDAB-46BF-B073-53A3CB61A1BE}" dt="2024-09-17T12:44:39.250" v="350" actId="47"/>
-        <pc:sldMkLst>
-          <pc:docMk/>
-          <pc:sldMk cId="125244385" sldId="341"/>
-        </pc:sldMkLst>
-        <pc:picChg chg="del">
-          <ac:chgData name="Janusz Stal" userId="570fe9c4-9123-4bde-9755-2a9767a29a9c" providerId="ADAL" clId="{23EEAE0B-FDAB-46BF-B073-53A3CB61A1BE}" dt="2024-09-17T11:51:59.818" v="25" actId="478"/>
-          <ac:picMkLst>
-            <pc:docMk/>
-            <pc:sldMk cId="125244385" sldId="341"/>
-            <ac:picMk id="6" creationId="{F89ED329-67DB-828A-C206-C0F849789148}"/>
-          </ac:picMkLst>
-        </pc:picChg>
-      </pc:sldChg>
-      <pc:sldChg chg="delSp modSp mod delAnim modNotesTx">
-        <pc:chgData name="Janusz Stal" userId="570fe9c4-9123-4bde-9755-2a9767a29a9c" providerId="ADAL" clId="{23EEAE0B-FDAB-46BF-B073-53A3CB61A1BE}" dt="2024-09-30T08:48:46.923" v="432" actId="20577"/>
-        <pc:sldMkLst>
-          <pc:docMk/>
-          <pc:sldMk cId="3170683099" sldId="342"/>
-        </pc:sldMkLst>
-        <pc:spChg chg="mod">
-          <ac:chgData name="Janusz Stal" userId="570fe9c4-9123-4bde-9755-2a9767a29a9c" providerId="ADAL" clId="{23EEAE0B-FDAB-46BF-B073-53A3CB61A1BE}" dt="2024-09-30T08:48:46.923" v="432" actId="20577"/>
-          <ac:spMkLst>
-            <pc:docMk/>
-            <pc:sldMk cId="3170683099" sldId="342"/>
-            <ac:spMk id="2" creationId="{323C843C-BB9F-F359-A3C4-389BFAB44E17}"/>
-          </ac:spMkLst>
-        </pc:spChg>
-        <pc:spChg chg="mod">
-          <ac:chgData name="Janusz Stal" userId="570fe9c4-9123-4bde-9755-2a9767a29a9c" providerId="ADAL" clId="{23EEAE0B-FDAB-46BF-B073-53A3CB61A1BE}" dt="2024-09-17T12:53:54.752" v="367" actId="20577"/>
-          <ac:spMkLst>
-            <pc:docMk/>
-            <pc:sldMk cId="3170683099" sldId="342"/>
-            <ac:spMk id="4" creationId="{1F28A227-2EE6-83AA-612F-04A8958950DA}"/>
-          </ac:spMkLst>
-        </pc:spChg>
-        <pc:picChg chg="del">
-          <ac:chgData name="Janusz Stal" userId="570fe9c4-9123-4bde-9755-2a9767a29a9c" providerId="ADAL" clId="{23EEAE0B-FDAB-46BF-B073-53A3CB61A1BE}" dt="2024-09-17T11:51:32.295" v="5" actId="478"/>
-          <ac:picMkLst>
-            <pc:docMk/>
-            <pc:sldMk cId="3170683099" sldId="342"/>
-            <ac:picMk id="6" creationId="{47CDD375-6F60-6EAE-5679-3C65421CCB27}"/>
-          </ac:picMkLst>
-        </pc:picChg>
-      </pc:sldChg>
-      <pc:sldChg chg="modSp add mod">
-        <pc:chgData name="Janusz Stal" userId="570fe9c4-9123-4bde-9755-2a9767a29a9c" providerId="ADAL" clId="{23EEAE0B-FDAB-46BF-B073-53A3CB61A1BE}" dt="2024-09-17T12:57:36.526" v="426" actId="207"/>
-        <pc:sldMkLst>
-          <pc:docMk/>
-          <pc:sldMk cId="4001945321" sldId="343"/>
-        </pc:sldMkLst>
-        <pc:spChg chg="mod">
-          <ac:chgData name="Janusz Stal" userId="570fe9c4-9123-4bde-9755-2a9767a29a9c" providerId="ADAL" clId="{23EEAE0B-FDAB-46BF-B073-53A3CB61A1BE}" dt="2024-09-17T12:57:36.526" v="426" actId="207"/>
-          <ac:spMkLst>
-            <pc:docMk/>
-            <pc:sldMk cId="4001945321" sldId="343"/>
-            <ac:spMk id="2" creationId="{323C843C-BB9F-F359-A3C4-389BFAB44E17}"/>
-          </ac:spMkLst>
-        </pc:spChg>
-        <pc:spChg chg="mod">
-          <ac:chgData name="Janusz Stal" userId="570fe9c4-9123-4bde-9755-2a9767a29a9c" providerId="ADAL" clId="{23EEAE0B-FDAB-46BF-B073-53A3CB61A1BE}" dt="2024-09-17T12:56:19.598" v="401" actId="20577"/>
-          <ac:spMkLst>
-            <pc:docMk/>
-            <pc:sldMk cId="4001945321" sldId="343"/>
-            <ac:spMk id="4" creationId="{1F28A227-2EE6-83AA-612F-04A8958950DA}"/>
-          </ac:spMkLst>
-        </pc:spChg>
-      </pc:sldChg>
-    </pc:docChg>
-  </pc:docChgLst>
-  <pc:docChgLst>
-    <pc:chgData name="Janusz Stal" userId="570fe9c4-9123-4bde-9755-2a9767a29a9c" providerId="ADAL" clId="{20650A6C-25D5-49EF-A71E-7B9E23599E6F}"/>
-    <pc:docChg chg="modSld">
-      <pc:chgData name="Janusz Stal" userId="570fe9c4-9123-4bde-9755-2a9767a29a9c" providerId="ADAL" clId="{20650A6C-25D5-49EF-A71E-7B9E23599E6F}" dt="2023-09-22T11:56:10.326" v="45"/>
-      <pc:docMkLst>
-        <pc:docMk/>
-      </pc:docMkLst>
-      <pc:sldChg chg="modAnim">
-        <pc:chgData name="Janusz Stal" userId="570fe9c4-9123-4bde-9755-2a9767a29a9c" providerId="ADAL" clId="{20650A6C-25D5-49EF-A71E-7B9E23599E6F}" dt="2023-09-22T11:54:47.591" v="21"/>
-        <pc:sldMkLst>
-          <pc:docMk/>
-          <pc:sldMk cId="3207883656" sldId="291"/>
-        </pc:sldMkLst>
-      </pc:sldChg>
-      <pc:sldChg chg="modAnim">
-        <pc:chgData name="Janusz Stal" userId="570fe9c4-9123-4bde-9755-2a9767a29a9c" providerId="ADAL" clId="{20650A6C-25D5-49EF-A71E-7B9E23599E6F}" dt="2023-09-22T11:53:44.884" v="3"/>
-        <pc:sldMkLst>
-          <pc:docMk/>
-          <pc:sldMk cId="665344467" sldId="304"/>
-        </pc:sldMkLst>
-      </pc:sldChg>
-      <pc:sldChg chg="modAnim">
-        <pc:chgData name="Janusz Stal" userId="570fe9c4-9123-4bde-9755-2a9767a29a9c" providerId="ADAL" clId="{20650A6C-25D5-49EF-A71E-7B9E23599E6F}" dt="2023-09-22T11:53:39.284" v="1"/>
-        <pc:sldMkLst>
-          <pc:docMk/>
-          <pc:sldMk cId="995346915" sldId="306"/>
-        </pc:sldMkLst>
-      </pc:sldChg>
-      <pc:sldChg chg="modAnim">
-        <pc:chgData name="Janusz Stal" userId="570fe9c4-9123-4bde-9755-2a9767a29a9c" providerId="ADAL" clId="{20650A6C-25D5-49EF-A71E-7B9E23599E6F}" dt="2023-09-22T11:53:58.953" v="7"/>
-        <pc:sldMkLst>
-          <pc:docMk/>
-          <pc:sldMk cId="481222839" sldId="307"/>
-        </pc:sldMkLst>
-      </pc:sldChg>
-      <pc:sldChg chg="modAnim">
-        <pc:chgData name="Janusz Stal" userId="570fe9c4-9123-4bde-9755-2a9767a29a9c" providerId="ADAL" clId="{20650A6C-25D5-49EF-A71E-7B9E23599E6F}" dt="2023-09-22T11:54:37.857" v="17"/>
-        <pc:sldMkLst>
-          <pc:docMk/>
-          <pc:sldMk cId="3376502272" sldId="312"/>
-        </pc:sldMkLst>
-      </pc:sldChg>
-      <pc:sldChg chg="modAnim">
-        <pc:chgData name="Janusz Stal" userId="570fe9c4-9123-4bde-9755-2a9767a29a9c" providerId="ADAL" clId="{20650A6C-25D5-49EF-A71E-7B9E23599E6F}" dt="2023-09-22T11:54:55.141" v="23"/>
-        <pc:sldMkLst>
-          <pc:docMk/>
-          <pc:sldMk cId="1144236073" sldId="316"/>
-        </pc:sldMkLst>
-      </pc:sldChg>
-      <pc:sldChg chg="modAnim">
-        <pc:chgData name="Janusz Stal" userId="570fe9c4-9123-4bde-9755-2a9767a29a9c" providerId="ADAL" clId="{20650A6C-25D5-49EF-A71E-7B9E23599E6F}" dt="2023-09-22T11:55:01.688" v="25"/>
-        <pc:sldMkLst>
-          <pc:docMk/>
-          <pc:sldMk cId="2533284800" sldId="317"/>
-        </pc:sldMkLst>
-      </pc:sldChg>
-      <pc:sldChg chg="modAnim">
-        <pc:chgData name="Janusz Stal" userId="570fe9c4-9123-4bde-9755-2a9767a29a9c" providerId="ADAL" clId="{20650A6C-25D5-49EF-A71E-7B9E23599E6F}" dt="2023-09-22T11:55:10.168" v="27"/>
-        <pc:sldMkLst>
-          <pc:docMk/>
-          <pc:sldMk cId="1234291028" sldId="318"/>
-        </pc:sldMkLst>
-      </pc:sldChg>
-      <pc:sldChg chg="modAnim">
-        <pc:chgData name="Janusz Stal" userId="570fe9c4-9123-4bde-9755-2a9767a29a9c" providerId="ADAL" clId="{20650A6C-25D5-49EF-A71E-7B9E23599E6F}" dt="2023-09-22T11:55:16.396" v="29"/>
-        <pc:sldMkLst>
-          <pc:docMk/>
-          <pc:sldMk cId="3984066826" sldId="319"/>
-        </pc:sldMkLst>
-      </pc:sldChg>
-      <pc:sldChg chg="modAnim">
-        <pc:chgData name="Janusz Stal" userId="570fe9c4-9123-4bde-9755-2a9767a29a9c" providerId="ADAL" clId="{20650A6C-25D5-49EF-A71E-7B9E23599E6F}" dt="2023-09-22T11:54:42.825" v="19"/>
-        <pc:sldMkLst>
-          <pc:docMk/>
-          <pc:sldMk cId="1005848108" sldId="320"/>
-        </pc:sldMkLst>
-      </pc:sldChg>
-      <pc:sldChg chg="modAnim">
-        <pc:chgData name="Janusz Stal" userId="570fe9c4-9123-4bde-9755-2a9767a29a9c" providerId="ADAL" clId="{20650A6C-25D5-49EF-A71E-7B9E23599E6F}" dt="2023-09-22T11:55:59.535" v="41"/>
-        <pc:sldMkLst>
-          <pc:docMk/>
-          <pc:sldMk cId="2525688714" sldId="323"/>
-        </pc:sldMkLst>
-      </pc:sldChg>
-      <pc:sldChg chg="modAnim">
-        <pc:chgData name="Janusz Stal" userId="570fe9c4-9123-4bde-9755-2a9767a29a9c" providerId="ADAL" clId="{20650A6C-25D5-49EF-A71E-7B9E23599E6F}" dt="2023-09-22T11:54:03.992" v="9"/>
-        <pc:sldMkLst>
-          <pc:docMk/>
-          <pc:sldMk cId="3622438534" sldId="328"/>
-        </pc:sldMkLst>
-      </pc:sldChg>
-      <pc:sldChg chg="modAnim">
-        <pc:chgData name="Janusz Stal" userId="570fe9c4-9123-4bde-9755-2a9767a29a9c" providerId="ADAL" clId="{20650A6C-25D5-49EF-A71E-7B9E23599E6F}" dt="2023-09-22T11:54:12.512" v="11"/>
-        <pc:sldMkLst>
-          <pc:docMk/>
-          <pc:sldMk cId="4232419462" sldId="329"/>
-        </pc:sldMkLst>
-      </pc:sldChg>
-      <pc:sldChg chg="modAnim">
-        <pc:chgData name="Janusz Stal" userId="570fe9c4-9123-4bde-9755-2a9767a29a9c" providerId="ADAL" clId="{20650A6C-25D5-49EF-A71E-7B9E23599E6F}" dt="2023-09-22T11:54:24.272" v="15"/>
-        <pc:sldMkLst>
-          <pc:docMk/>
-          <pc:sldMk cId="322425298" sldId="330"/>
-        </pc:sldMkLst>
-      </pc:sldChg>
-      <pc:sldChg chg="modAnim">
-        <pc:chgData name="Janusz Stal" userId="570fe9c4-9123-4bde-9755-2a9767a29a9c" providerId="ADAL" clId="{20650A6C-25D5-49EF-A71E-7B9E23599E6F}" dt="2023-09-22T11:54:18.886" v="13"/>
-        <pc:sldMkLst>
-          <pc:docMk/>
-          <pc:sldMk cId="1840778044" sldId="332"/>
-        </pc:sldMkLst>
-      </pc:sldChg>
-      <pc:sldChg chg="modAnim">
-        <pc:chgData name="Janusz Stal" userId="570fe9c4-9123-4bde-9755-2a9767a29a9c" providerId="ADAL" clId="{20650A6C-25D5-49EF-A71E-7B9E23599E6F}" dt="2023-09-22T11:55:34.364" v="33"/>
-        <pc:sldMkLst>
-          <pc:docMk/>
-          <pc:sldMk cId="3714800936" sldId="333"/>
-        </pc:sldMkLst>
-      </pc:sldChg>
-      <pc:sldChg chg="modAnim">
-        <pc:chgData name="Janusz Stal" userId="570fe9c4-9123-4bde-9755-2a9767a29a9c" providerId="ADAL" clId="{20650A6C-25D5-49EF-A71E-7B9E23599E6F}" dt="2023-09-22T11:55:40.131" v="35"/>
-        <pc:sldMkLst>
-          <pc:docMk/>
-          <pc:sldMk cId="2277860244" sldId="334"/>
-        </pc:sldMkLst>
-      </pc:sldChg>
-      <pc:sldChg chg="modAnim">
-        <pc:chgData name="Janusz Stal" userId="570fe9c4-9123-4bde-9755-2a9767a29a9c" providerId="ADAL" clId="{20650A6C-25D5-49EF-A71E-7B9E23599E6F}" dt="2023-09-22T11:55:25.624" v="31"/>
-        <pc:sldMkLst>
-          <pc:docMk/>
-          <pc:sldMk cId="2173447150" sldId="335"/>
-        </pc:sldMkLst>
-      </pc:sldChg>
-      <pc:sldChg chg="modAnim">
-        <pc:chgData name="Janusz Stal" userId="570fe9c4-9123-4bde-9755-2a9767a29a9c" providerId="ADAL" clId="{20650A6C-25D5-49EF-A71E-7B9E23599E6F}" dt="2023-09-22T11:55:54.247" v="39"/>
-        <pc:sldMkLst>
-          <pc:docMk/>
-          <pc:sldMk cId="3123027594" sldId="336"/>
-        </pc:sldMkLst>
-      </pc:sldChg>
-      <pc:sldChg chg="modAnim">
-        <pc:chgData name="Janusz Stal" userId="570fe9c4-9123-4bde-9755-2a9767a29a9c" providerId="ADAL" clId="{20650A6C-25D5-49EF-A71E-7B9E23599E6F}" dt="2023-09-22T11:55:45.726" v="37"/>
-        <pc:sldMkLst>
-          <pc:docMk/>
-          <pc:sldMk cId="3617956429" sldId="337"/>
-        </pc:sldMkLst>
-      </pc:sldChg>
-      <pc:sldChg chg="modAnim">
-        <pc:chgData name="Janusz Stal" userId="570fe9c4-9123-4bde-9755-2a9767a29a9c" providerId="ADAL" clId="{20650A6C-25D5-49EF-A71E-7B9E23599E6F}" dt="2023-09-22T11:56:04.716" v="43"/>
-        <pc:sldMkLst>
-          <pc:docMk/>
-          <pc:sldMk cId="1809690938" sldId="340"/>
-        </pc:sldMkLst>
-      </pc:sldChg>
-      <pc:sldChg chg="modAnim">
-        <pc:chgData name="Janusz Stal" userId="570fe9c4-9123-4bde-9755-2a9767a29a9c" providerId="ADAL" clId="{20650A6C-25D5-49EF-A71E-7B9E23599E6F}" dt="2023-09-22T11:56:10.326" v="45"/>
-        <pc:sldMkLst>
-          <pc:docMk/>
-          <pc:sldMk cId="125244385" sldId="341"/>
-        </pc:sldMkLst>
-      </pc:sldChg>
-      <pc:sldChg chg="modAnim">
-        <pc:chgData name="Janusz Stal" userId="570fe9c4-9123-4bde-9755-2a9767a29a9c" providerId="ADAL" clId="{20650A6C-25D5-49EF-A71E-7B9E23599E6F}" dt="2023-09-22T11:53:53.508" v="5"/>
+      <pc:sldChg chg="del">
+        <pc:chgData name="Janusz Stal" userId="570fe9c4-9123-4bde-9755-2a9767a29a9c" providerId="ADAL" clId="{93B0BD34-580E-4F7F-A301-D1F6EE30DB68}" dt="2026-10-03T15:56:08.274" v="64" actId="2696"/>
         <pc:sldMkLst>
           <pc:docMk/>
           <pc:sldMk cId="3170683099" sldId="342"/>
@@ -1368,7 +301,7 @@
           <a:p>
             <a:fld id="{C106EF3D-C2A7-4690-80C8-C2473A856193}" type="datetimeFigureOut">
               <a:rPr lang="pl-PL" smtClean="0"/>
-              <a:t>30.09.2024</a:t>
+              <a:t>03.10.2026</a:t>
             </a:fld>
             <a:endParaRPr lang="pl-PL" dirty="0"/>
           </a:p>
@@ -1533,7 +466,7 @@
           <a:p>
             <a:fld id="{85D68E81-03CD-43A1-B18B-BEB6B9439387}" type="datetimeFigureOut">
               <a:rPr lang="pl-PL" smtClean="0"/>
-              <a:t>30.09.2024</a:t>
+              <a:t>03.10.2026</a:t>
             </a:fld>
             <a:endParaRPr lang="pl-PL" dirty="0"/>
           </a:p>
@@ -1958,7 +891,7 @@
     </p:spTree>
     <p:extLst>
       <p:ext uri="{BB962C8B-B14F-4D97-AF65-F5344CB8AC3E}">
-        <p14:creationId xmlns:p14="http://schemas.microsoft.com/office/powerpoint/2010/main" val="4234834416"/>
+        <p14:creationId xmlns:p14="http://schemas.microsoft.com/office/powerpoint/2010/main" val="3029718517"/>
       </p:ext>
     </p:extLst>
   </p:cSld>
@@ -2042,7 +975,7 @@
     </p:spTree>
     <p:extLst>
       <p:ext uri="{BB962C8B-B14F-4D97-AF65-F5344CB8AC3E}">
-        <p14:creationId xmlns:p14="http://schemas.microsoft.com/office/powerpoint/2010/main" val="3029718517"/>
+        <p14:creationId xmlns:p14="http://schemas.microsoft.com/office/powerpoint/2010/main" val="3812384923"/>
       </p:ext>
     </p:extLst>
   </p:cSld>
@@ -2126,7 +1059,7 @@
     </p:spTree>
     <p:extLst>
       <p:ext uri="{BB962C8B-B14F-4D97-AF65-F5344CB8AC3E}">
-        <p14:creationId xmlns:p14="http://schemas.microsoft.com/office/powerpoint/2010/main" val="3812384923"/>
+        <p14:creationId xmlns:p14="http://schemas.microsoft.com/office/powerpoint/2010/main" val="411122275"/>
       </p:ext>
     </p:extLst>
   </p:cSld>
@@ -2210,7 +1143,7 @@
     </p:spTree>
     <p:extLst>
       <p:ext uri="{BB962C8B-B14F-4D97-AF65-F5344CB8AC3E}">
-        <p14:creationId xmlns:p14="http://schemas.microsoft.com/office/powerpoint/2010/main" val="411122275"/>
+        <p14:creationId xmlns:p14="http://schemas.microsoft.com/office/powerpoint/2010/main" val="132462848"/>
       </p:ext>
     </p:extLst>
   </p:cSld>
@@ -2294,7 +1227,7 @@
     </p:spTree>
     <p:extLst>
       <p:ext uri="{BB962C8B-B14F-4D97-AF65-F5344CB8AC3E}">
-        <p14:creationId xmlns:p14="http://schemas.microsoft.com/office/powerpoint/2010/main" val="132462848"/>
+        <p14:creationId xmlns:p14="http://schemas.microsoft.com/office/powerpoint/2010/main" val="3613054228"/>
       </p:ext>
     </p:extLst>
   </p:cSld>
@@ -2378,7 +1311,7 @@
     </p:spTree>
     <p:extLst>
       <p:ext uri="{BB962C8B-B14F-4D97-AF65-F5344CB8AC3E}">
-        <p14:creationId xmlns:p14="http://schemas.microsoft.com/office/powerpoint/2010/main" val="3613054228"/>
+        <p14:creationId xmlns:p14="http://schemas.microsoft.com/office/powerpoint/2010/main" val="3939967312"/>
       </p:ext>
     </p:extLst>
   </p:cSld>
@@ -2462,7 +1395,7 @@
     </p:spTree>
     <p:extLst>
       <p:ext uri="{BB962C8B-B14F-4D97-AF65-F5344CB8AC3E}">
-        <p14:creationId xmlns:p14="http://schemas.microsoft.com/office/powerpoint/2010/main" val="3939967312"/>
+        <p14:creationId xmlns:p14="http://schemas.microsoft.com/office/powerpoint/2010/main" val="2874145930"/>
       </p:ext>
     </p:extLst>
   </p:cSld>
@@ -2516,6 +1449,23 @@
           <a:bodyPr/>
           <a:lstStyle/>
           <a:p>
+            <a:pPr marL="0" marR="0" lvl="0" indent="0" algn="l" defTabSz="914400" rtl="0" eaLnBrk="1" fontAlgn="auto" latinLnBrk="0" hangingPunct="1">
+              <a:lnSpc>
+                <a:spcPct val="100000"/>
+              </a:lnSpc>
+              <a:spcBef>
+                <a:spcPts val="0"/>
+              </a:spcBef>
+              <a:spcAft>
+                <a:spcPts val="0"/>
+              </a:spcAft>
+              <a:buClrTx/>
+              <a:buSzTx/>
+              <a:buFontTx/>
+              <a:buNone/>
+              <a:tabLst/>
+              <a:defRPr/>
+            </a:pPr>
             <a:endParaRPr lang="pl-PL" dirty="0"/>
           </a:p>
         </p:txBody>
@@ -2546,7 +1496,7 @@
     </p:spTree>
     <p:extLst>
       <p:ext uri="{BB962C8B-B14F-4D97-AF65-F5344CB8AC3E}">
-        <p14:creationId xmlns:p14="http://schemas.microsoft.com/office/powerpoint/2010/main" val="2874145930"/>
+        <p14:creationId xmlns:p14="http://schemas.microsoft.com/office/powerpoint/2010/main" val="1298777106"/>
       </p:ext>
     </p:extLst>
   </p:cSld>
@@ -2600,23 +1550,6 @@
           <a:bodyPr/>
           <a:lstStyle/>
           <a:p>
-            <a:pPr marL="0" marR="0" lvl="0" indent="0" algn="l" defTabSz="914400" rtl="0" eaLnBrk="1" fontAlgn="auto" latinLnBrk="0" hangingPunct="1">
-              <a:lnSpc>
-                <a:spcPct val="100000"/>
-              </a:lnSpc>
-              <a:spcBef>
-                <a:spcPts val="0"/>
-              </a:spcBef>
-              <a:spcAft>
-                <a:spcPts val="0"/>
-              </a:spcAft>
-              <a:buClrTx/>
-              <a:buSzTx/>
-              <a:buFontTx/>
-              <a:buNone/>
-              <a:tabLst/>
-              <a:defRPr/>
-            </a:pPr>
             <a:endParaRPr lang="pl-PL" dirty="0"/>
           </a:p>
         </p:txBody>
@@ -2647,7 +1580,7 @@
     </p:spTree>
     <p:extLst>
       <p:ext uri="{BB962C8B-B14F-4D97-AF65-F5344CB8AC3E}">
-        <p14:creationId xmlns:p14="http://schemas.microsoft.com/office/powerpoint/2010/main" val="1298777106"/>
+        <p14:creationId xmlns:p14="http://schemas.microsoft.com/office/powerpoint/2010/main" val="547774683"/>
       </p:ext>
     </p:extLst>
   </p:cSld>
@@ -2731,7 +1664,7 @@
     </p:spTree>
     <p:extLst>
       <p:ext uri="{BB962C8B-B14F-4D97-AF65-F5344CB8AC3E}">
-        <p14:creationId xmlns:p14="http://schemas.microsoft.com/office/powerpoint/2010/main" val="547774683"/>
+        <p14:creationId xmlns:p14="http://schemas.microsoft.com/office/powerpoint/2010/main" val="3218106768"/>
       </p:ext>
     </p:extLst>
   </p:cSld>
@@ -2899,90 +1832,6 @@
     </p:spTree>
     <p:extLst>
       <p:ext uri="{BB962C8B-B14F-4D97-AF65-F5344CB8AC3E}">
-        <p14:creationId xmlns:p14="http://schemas.microsoft.com/office/powerpoint/2010/main" val="3218106768"/>
-      </p:ext>
-    </p:extLst>
-  </p:cSld>
-  <p:clrMapOvr>
-    <a:masterClrMapping/>
-  </p:clrMapOvr>
-</p:notes>
-</file>
-
-<file path=ppt/notesSlides/notesSlide21.xml><?xml version="1.0" encoding="utf-8"?>
-<p:notes xmlns:a="http://schemas.openxmlformats.org/drawingml/2006/main" xmlns:r="http://schemas.openxmlformats.org/officeDocument/2006/relationships" xmlns:p="http://schemas.openxmlformats.org/presentationml/2006/main">
-  <p:cSld>
-    <p:spTree>
-      <p:nvGrpSpPr>
-        <p:cNvPr id="1" name=""/>
-        <p:cNvGrpSpPr/>
-        <p:nvPr/>
-      </p:nvGrpSpPr>
-      <p:grpSpPr>
-        <a:xfrm>
-          <a:off x="0" y="0"/>
-          <a:ext cx="0" cy="0"/>
-          <a:chOff x="0" y="0"/>
-          <a:chExt cx="0" cy="0"/>
-        </a:xfrm>
-      </p:grpSpPr>
-      <p:sp>
-        <p:nvSpPr>
-          <p:cNvPr id="2" name="Symbol zastępczy obrazu slajdu 1"/>
-          <p:cNvSpPr>
-            <a:spLocks noGrp="1" noRot="1" noChangeAspect="1"/>
-          </p:cNvSpPr>
-          <p:nvPr>
-            <p:ph type="sldImg"/>
-          </p:nvPr>
-        </p:nvSpPr>
-        <p:spPr/>
-      </p:sp>
-      <p:sp>
-        <p:nvSpPr>
-          <p:cNvPr id="3" name="Symbol zastępczy notatek 2"/>
-          <p:cNvSpPr>
-            <a:spLocks noGrp="1"/>
-          </p:cNvSpPr>
-          <p:nvPr>
-            <p:ph type="body" idx="1"/>
-          </p:nvPr>
-        </p:nvSpPr>
-        <p:spPr/>
-        <p:txBody>
-          <a:bodyPr/>
-          <a:lstStyle/>
-          <a:p>
-            <a:endParaRPr lang="pl-PL" dirty="0"/>
-          </a:p>
-        </p:txBody>
-      </p:sp>
-      <p:sp>
-        <p:nvSpPr>
-          <p:cNvPr id="4" name="Symbol zastępczy numeru slajdu 3"/>
-          <p:cNvSpPr>
-            <a:spLocks noGrp="1"/>
-          </p:cNvSpPr>
-          <p:nvPr>
-            <p:ph type="sldNum" sz="quarter" idx="5"/>
-          </p:nvPr>
-        </p:nvSpPr>
-        <p:spPr/>
-        <p:txBody>
-          <a:bodyPr/>
-          <a:lstStyle/>
-          <a:p>
-            <a:fld id="{A57965AB-F56B-43E1-8FC6-BF0F64E550D5}" type="slidenum">
-              <a:rPr lang="pl-PL" smtClean="0"/>
-              <a:t>21</a:t>
-            </a:fld>
-            <a:endParaRPr lang="pl-PL" dirty="0"/>
-          </a:p>
-        </p:txBody>
-      </p:sp>
-    </p:spTree>
-    <p:extLst>
-      <p:ext uri="{BB962C8B-B14F-4D97-AF65-F5344CB8AC3E}">
         <p14:creationId xmlns:p14="http://schemas.microsoft.com/office/powerpoint/2010/main" val="3866215756"/>
       </p:ext>
     </p:extLst>
@@ -3319,7 +2168,7 @@
     </p:spTree>
     <p:extLst>
       <p:ext uri="{BB962C8B-B14F-4D97-AF65-F5344CB8AC3E}">
-        <p14:creationId xmlns:p14="http://schemas.microsoft.com/office/powerpoint/2010/main" val="1464182208"/>
+        <p14:creationId xmlns:p14="http://schemas.microsoft.com/office/powerpoint/2010/main" val="3656928766"/>
       </p:ext>
     </p:extLst>
   </p:cSld>
@@ -3403,7 +2252,7 @@
     </p:spTree>
     <p:extLst>
       <p:ext uri="{BB962C8B-B14F-4D97-AF65-F5344CB8AC3E}">
-        <p14:creationId xmlns:p14="http://schemas.microsoft.com/office/powerpoint/2010/main" val="3656928766"/>
+        <p14:creationId xmlns:p14="http://schemas.microsoft.com/office/powerpoint/2010/main" val="381066679"/>
       </p:ext>
     </p:extLst>
   </p:cSld>
@@ -3487,7 +2336,7 @@
     </p:spTree>
     <p:extLst>
       <p:ext uri="{BB962C8B-B14F-4D97-AF65-F5344CB8AC3E}">
-        <p14:creationId xmlns:p14="http://schemas.microsoft.com/office/powerpoint/2010/main" val="381066679"/>
+        <p14:creationId xmlns:p14="http://schemas.microsoft.com/office/powerpoint/2010/main" val="1643569153"/>
       </p:ext>
     </p:extLst>
   </p:cSld>
@@ -3571,7 +2420,7 @@
     </p:spTree>
     <p:extLst>
       <p:ext uri="{BB962C8B-B14F-4D97-AF65-F5344CB8AC3E}">
-        <p14:creationId xmlns:p14="http://schemas.microsoft.com/office/powerpoint/2010/main" val="1643569153"/>
+        <p14:creationId xmlns:p14="http://schemas.microsoft.com/office/powerpoint/2010/main" val="4234834416"/>
       </p:ext>
     </p:extLst>
   </p:cSld>
@@ -3710,7 +2559,7 @@
           <a:p>
             <a:fld id="{F26B3061-B9B7-461F-AB67-5D66A3ABCDA5}" type="datetime1">
               <a:rPr lang="pl-PL" smtClean="0"/>
-              <a:t>30.09.2024</a:t>
+              <a:t>03.10.2026</a:t>
             </a:fld>
             <a:endParaRPr lang="pl-PL" dirty="0"/>
           </a:p>
@@ -3985,7 +2834,7 @@
           <a:p>
             <a:fld id="{A2ADAE54-1728-4B6D-BEF4-D2AEA4F8114E}" type="datetime1">
               <a:rPr lang="pl-PL" smtClean="0"/>
-              <a:t>30.09.2024</a:t>
+              <a:t>03.10.2026</a:t>
             </a:fld>
             <a:endParaRPr lang="pl-PL" dirty="0"/>
           </a:p>
@@ -4237,7 +3086,7 @@
           <a:p>
             <a:fld id="{919C3B4F-179D-44ED-90DF-E8739DC8608F}" type="datetime1">
               <a:rPr lang="pl-PL" smtClean="0"/>
-              <a:t>30.09.2024</a:t>
+              <a:t>03.10.2026</a:t>
             </a:fld>
             <a:endParaRPr lang="pl-PL" dirty="0"/>
           </a:p>
@@ -4405,7 +3254,7 @@
           <a:p>
             <a:fld id="{10A2297D-8C4B-4C5B-B66E-47E601842B03}" type="datetime1">
               <a:rPr lang="pl-PL" smtClean="0"/>
-              <a:t>30.09.2024</a:t>
+              <a:t>03.10.2026</a:t>
             </a:fld>
             <a:endParaRPr lang="pl-PL" dirty="0"/>
           </a:p>
@@ -4583,7 +3432,7 @@
           <a:p>
             <a:fld id="{94B42B50-113C-45E3-9231-B66C297B394E}" type="datetime1">
               <a:rPr lang="pl-PL" smtClean="0"/>
-              <a:t>30.09.2024</a:t>
+              <a:t>03.10.2026</a:t>
             </a:fld>
             <a:endParaRPr lang="pl-PL" dirty="0"/>
           </a:p>
@@ -4740,7 +3589,7 @@
           <a:p>
             <a:fld id="{9549FAE5-AB97-492F-ADAE-06E72624D9F3}" type="datetime1">
               <a:rPr lang="pl-PL" smtClean="0"/>
-              <a:t>30.09.2024</a:t>
+              <a:t>03.10.2026</a:t>
             </a:fld>
             <a:endParaRPr lang="pl-PL" dirty="0"/>
           </a:p>
@@ -4928,7 +3777,7 @@
           <a:p>
             <a:fld id="{9549FAE5-AB97-492F-ADAE-06E72624D9F3}" type="datetime1">
               <a:rPr lang="pl-PL" smtClean="0"/>
-              <a:t>30.09.2024</a:t>
+              <a:t>03.10.2026</a:t>
             </a:fld>
             <a:endParaRPr lang="pl-PL" dirty="0"/>
           </a:p>
@@ -5115,7 +3964,7 @@
           <a:p>
             <a:fld id="{9549FAE5-AB97-492F-ADAE-06E72624D9F3}" type="datetime1">
               <a:rPr lang="pl-PL" smtClean="0"/>
-              <a:t>30.09.2024</a:t>
+              <a:t>03.10.2026</a:t>
             </a:fld>
             <a:endParaRPr lang="pl-PL" dirty="0"/>
           </a:p>
@@ -5387,7 +4236,7 @@
           <a:p>
             <a:fld id="{ED0EDA0A-F020-4B01-AF63-E290248EFD6B}" type="datetime1">
               <a:rPr lang="pl-PL" smtClean="0"/>
-              <a:t>30.09.2024</a:t>
+              <a:t>03.10.2026</a:t>
             </a:fld>
             <a:endParaRPr lang="pl-PL" dirty="0"/>
           </a:p>
@@ -5643,7 +4492,7 @@
           <a:p>
             <a:fld id="{8B752FBA-2CC8-4F32-B36A-B6E16B4A5C14}" type="datetime1">
               <a:rPr lang="pl-PL" smtClean="0"/>
-              <a:t>30.09.2024</a:t>
+              <a:t>03.10.2026</a:t>
             </a:fld>
             <a:endParaRPr lang="pl-PL" dirty="0"/>
           </a:p>
@@ -6029,7 +4878,7 @@
           <a:p>
             <a:fld id="{3B7BA32A-B79B-42FE-906A-2593AD6A7FCC}" type="datetime1">
               <a:rPr lang="pl-PL" smtClean="0"/>
-              <a:t>30.09.2024</a:t>
+              <a:t>03.10.2026</a:t>
             </a:fld>
             <a:endParaRPr lang="pl-PL" dirty="0"/>
           </a:p>
@@ -6151,7 +5000,7 @@
           <a:p>
             <a:fld id="{3E28EDCB-CC2B-4C70-B921-DD5382BD4849}" type="datetime1">
               <a:rPr lang="pl-PL" smtClean="0"/>
-              <a:t>30.09.2024</a:t>
+              <a:t>03.10.2026</a:t>
             </a:fld>
             <a:endParaRPr lang="pl-PL" dirty="0"/>
           </a:p>
@@ -6246,7 +5095,7 @@
           <a:p>
             <a:fld id="{E960CF9B-2F8C-4614-93FE-75BD5748BF99}" type="datetime1">
               <a:rPr lang="pl-PL" smtClean="0"/>
-              <a:t>30.09.2024</a:t>
+              <a:t>03.10.2026</a:t>
             </a:fld>
             <a:endParaRPr lang="pl-PL" dirty="0"/>
           </a:p>
@@ -6462,7 +5311,7 @@
           <a:p>
             <a:fld id="{8F276EAB-4011-4C81-ACEC-B79731A9A244}" type="datetime1">
               <a:rPr lang="pl-PL" smtClean="0"/>
-              <a:t>30.09.2024</a:t>
+              <a:t>03.10.2026</a:t>
             </a:fld>
             <a:endParaRPr lang="pl-PL" dirty="0"/>
           </a:p>
@@ -6883,22 +5732,21 @@
         <p:spPr/>
         <p:txBody>
           <a:bodyPr>
-            <a:normAutofit/>
+            <a:normAutofit fontScale="90000"/>
           </a:bodyPr>
           <a:lstStyle/>
           <a:p>
             <a:r>
               <a:rPr lang="pl-PL" dirty="0"/>
+              <a:t>Fundamentals of Programming</a:t>
+            </a:r>
+            <a:br>
+              <a:rPr lang="pl-PL" dirty="0"/>
+            </a:br>
+            <a:r>
+              <a:rPr lang="pl-PL" dirty="0"/>
               <a:t>Podstawy Programowania</a:t>
             </a:r>
-            <a:br>
-              <a:rPr lang="pl-PL" dirty="0"/>
-            </a:br>
-            <a:r>
-              <a:rPr lang="en-US" dirty="0"/>
-              <a:t>Computer Programming 1</a:t>
-            </a:r>
-            <a:endParaRPr lang="pl-PL" dirty="0"/>
           </a:p>
         </p:txBody>
       </p:sp>
@@ -6917,16 +5765,6 @@
           <a:bodyPr/>
           <a:lstStyle/>
           <a:p>
-            <a:r>
-              <a:rPr lang="pl-PL" dirty="0"/>
-              <a:t>PRG-BASICS</a:t>
-            </a:r>
-          </a:p>
-          <a:p>
-            <a:r>
-              <a:rPr lang="pl-PL" dirty="0"/>
-              <a:t> </a:t>
-            </a:r>
             <a:r>
               <a:rPr lang="en-US" dirty="0"/>
               <a:t>Course Introduction</a:t>
@@ -6978,219 +5816,6 @@
       </p:grpSpPr>
       <p:sp>
         <p:nvSpPr>
-          <p:cNvPr id="6" name="Symbol zastępczy zawartości 5">
-            <a:extLst>
-              <a:ext uri="{FF2B5EF4-FFF2-40B4-BE49-F238E27FC236}">
-                <a16:creationId xmlns:a16="http://schemas.microsoft.com/office/drawing/2014/main" id="{3BEF4DD1-DF03-4BD7-972C-609EAA9D84FC}"/>
-              </a:ext>
-            </a:extLst>
-          </p:cNvPr>
-          <p:cNvSpPr>
-            <a:spLocks noGrp="1"/>
-          </p:cNvSpPr>
-          <p:nvPr>
-            <p:ph idx="1"/>
-          </p:nvPr>
-        </p:nvSpPr>
-        <p:spPr/>
-        <p:txBody>
-          <a:bodyPr>
-            <a:normAutofit/>
-          </a:bodyPr>
-          <a:lstStyle/>
-          <a:p>
-            <a:pPr marL="514350" indent="-514350">
-              <a:buFont typeface="+mj-lt"/>
-              <a:buAutoNum type="arabicPeriod"/>
-            </a:pPr>
-            <a:r>
-              <a:rPr lang="pl-PL" dirty="0"/>
-              <a:t>Run Microsoft </a:t>
-            </a:r>
-            <a:r>
-              <a:rPr lang="pl-PL" dirty="0" err="1"/>
-              <a:t>Teams</a:t>
-            </a:r>
-            <a:endParaRPr lang="pl-PL" dirty="0"/>
-          </a:p>
-          <a:p>
-            <a:pPr marL="514350" indent="-514350">
-              <a:buFont typeface="+mj-lt"/>
-              <a:buAutoNum type="arabicPeriod"/>
-            </a:pPr>
-            <a:r>
-              <a:rPr lang="en-US" dirty="0"/>
-              <a:t>Log in to your account</a:t>
-            </a:r>
-          </a:p>
-          <a:p>
-            <a:pPr marL="514350" indent="-514350">
-              <a:buFont typeface="+mj-lt"/>
-              <a:buAutoNum type="arabicPeriod"/>
-            </a:pPr>
-            <a:r>
-              <a:rPr lang="pl-PL" dirty="0"/>
-              <a:t>Display team list</a:t>
-            </a:r>
-          </a:p>
-          <a:p>
-            <a:pPr marL="514350" indent="-514350">
-              <a:buFont typeface="+mj-lt"/>
-              <a:buAutoNum type="arabicPeriod"/>
-            </a:pPr>
-            <a:r>
-              <a:rPr lang="pl-PL" dirty="0"/>
-              <a:t>Select „</a:t>
-            </a:r>
-            <a:r>
-              <a:rPr lang="pl-PL" dirty="0" err="1"/>
-              <a:t>join</a:t>
-            </a:r>
-            <a:r>
-              <a:rPr lang="pl-PL" dirty="0"/>
-              <a:t> a team”</a:t>
-            </a:r>
-          </a:p>
-          <a:p>
-            <a:pPr marL="514350" indent="-514350">
-              <a:buFont typeface="+mj-lt"/>
-              <a:buAutoNum type="arabicPeriod"/>
-            </a:pPr>
-            <a:r>
-              <a:rPr lang="pl-PL" dirty="0" err="1"/>
-              <a:t>Use</a:t>
-            </a:r>
-            <a:r>
-              <a:rPr lang="pl-PL" dirty="0"/>
-              <a:t> a team code</a:t>
-            </a:r>
-            <a:br>
-              <a:rPr lang="pl-PL" dirty="0"/>
-            </a:br>
-            <a:r>
-              <a:rPr lang="pl-PL" dirty="0">
-                <a:solidFill>
-                  <a:srgbClr val="00B0F0"/>
-                </a:solidFill>
-              </a:rPr>
-              <a:t>76wfate</a:t>
-            </a:r>
-          </a:p>
-        </p:txBody>
-      </p:sp>
-      <p:sp>
-        <p:nvSpPr>
-          <p:cNvPr id="4" name="Symbol zastępczy numeru slajdu 3">
-            <a:extLst>
-              <a:ext uri="{FF2B5EF4-FFF2-40B4-BE49-F238E27FC236}">
-                <a16:creationId xmlns:a16="http://schemas.microsoft.com/office/drawing/2014/main" id="{A9E7A3CE-C572-405A-92A2-0E1533B68464}"/>
-              </a:ext>
-            </a:extLst>
-          </p:cNvPr>
-          <p:cNvSpPr>
-            <a:spLocks noGrp="1"/>
-          </p:cNvSpPr>
-          <p:nvPr>
-            <p:ph type="sldNum" sz="quarter" idx="12"/>
-          </p:nvPr>
-        </p:nvSpPr>
-        <p:spPr/>
-        <p:txBody>
-          <a:bodyPr/>
-          <a:lstStyle/>
-          <a:p>
-            <a:fld id="{254C963F-D690-449C-B336-8B464EE7B8DB}" type="slidenum">
-              <a:rPr lang="en-US" smtClean="0"/>
-              <a:t>10</a:t>
-            </a:fld>
-            <a:endParaRPr lang="en-US" dirty="0"/>
-          </a:p>
-        </p:txBody>
-      </p:sp>
-      <p:sp>
-        <p:nvSpPr>
-          <p:cNvPr id="5" name="Tytuł 4">
-            <a:extLst>
-              <a:ext uri="{FF2B5EF4-FFF2-40B4-BE49-F238E27FC236}">
-                <a16:creationId xmlns:a16="http://schemas.microsoft.com/office/drawing/2014/main" id="{E5EAA86D-7FAF-4F5F-B693-8A5642336538}"/>
-              </a:ext>
-            </a:extLst>
-          </p:cNvPr>
-          <p:cNvSpPr>
-            <a:spLocks noGrp="1"/>
-          </p:cNvSpPr>
-          <p:nvPr>
-            <p:ph type="title"/>
-          </p:nvPr>
-        </p:nvSpPr>
-        <p:spPr/>
-        <p:txBody>
-          <a:bodyPr/>
-          <a:lstStyle/>
-          <a:p>
-            <a:r>
-              <a:rPr lang="en-US" dirty="0"/>
-              <a:t>Sign up for </a:t>
-            </a:r>
-            <a:r>
-              <a:rPr lang="pl-PL" dirty="0"/>
-              <a:t>C</a:t>
-            </a:r>
-            <a:r>
-              <a:rPr lang="en-US" dirty="0" err="1"/>
-              <a:t>ourse</a:t>
-            </a:r>
-            <a:r>
-              <a:rPr lang="en-US" dirty="0"/>
-              <a:t> on Teams</a:t>
-            </a:r>
-          </a:p>
-        </p:txBody>
-      </p:sp>
-    </p:spTree>
-    <p:extLst>
-      <p:ext uri="{BB962C8B-B14F-4D97-AF65-F5344CB8AC3E}">
-        <p14:creationId xmlns:p14="http://schemas.microsoft.com/office/powerpoint/2010/main" val="3207883656"/>
-      </p:ext>
-    </p:extLst>
-  </p:cSld>
-  <p:clrMapOvr>
-    <a:masterClrMapping/>
-  </p:clrMapOvr>
-  <mc:AlternateContent xmlns:mc="http://schemas.openxmlformats.org/markup-compatibility/2006" xmlns:p14="http://schemas.microsoft.com/office/powerpoint/2010/main">
-    <mc:Choice Requires="p14">
-      <p:transition spd="slow" p14:dur="1200" advTm="30614">
-        <p14:prism/>
-      </p:transition>
-    </mc:Choice>
-    <mc:Fallback xmlns="">
-      <p:transition spd="slow" advTm="30614">
-        <p:fade/>
-      </p:transition>
-    </mc:Fallback>
-  </mc:AlternateContent>
-</p:sld>
-</file>
-
-<file path=ppt/slides/slide11.xml><?xml version="1.0" encoding="utf-8"?>
-<p:sld xmlns:a="http://schemas.openxmlformats.org/drawingml/2006/main" xmlns:r="http://schemas.openxmlformats.org/officeDocument/2006/relationships" xmlns:p="http://schemas.openxmlformats.org/presentationml/2006/main">
-  <p:cSld>
-    <p:spTree>
-      <p:nvGrpSpPr>
-        <p:cNvPr id="1" name=""/>
-        <p:cNvGrpSpPr/>
-        <p:nvPr/>
-      </p:nvGrpSpPr>
-      <p:grpSpPr>
-        <a:xfrm>
-          <a:off x="0" y="0"/>
-          <a:ext cx="0" cy="0"/>
-          <a:chOff x="0" y="0"/>
-          <a:chExt cx="0" cy="0"/>
-        </a:xfrm>
-      </p:grpSpPr>
-      <p:sp>
-        <p:nvSpPr>
           <p:cNvPr id="2" name="Symbol zastępczy zawartości 1">
             <a:extLst>
               <a:ext uri="{FF2B5EF4-FFF2-40B4-BE49-F238E27FC236}">
@@ -7250,8 +5875,17 @@
             </a:r>
             <a:r>
               <a:rPr lang="en-US" dirty="0"/>
-              <a:t> / Computer Programming 1</a:t>
-            </a:r>
+              <a:t> /</a:t>
+            </a:r>
+            <a:r>
+              <a:rPr lang="pl-PL" dirty="0"/>
+              <a:t> Fundamentals </a:t>
+            </a:r>
+            <a:r>
+              <a:rPr lang="pl-PL"/>
+              <a:t>of Programming</a:t>
+            </a:r>
+            <a:endParaRPr lang="en-US" dirty="0"/>
           </a:p>
           <a:p>
             <a:pPr marL="514350" indent="-514350">
@@ -7307,7 +5941,7 @@
           <a:p>
             <a:fld id="{254C963F-D690-449C-B336-8B464EE7B8DB}" type="slidenum">
               <a:rPr lang="pl-PL" smtClean="0"/>
-              <a:t>11</a:t>
+              <a:t>10</a:t>
             </a:fld>
             <a:endParaRPr lang="pl-PL" dirty="0"/>
           </a:p>
@@ -7366,7 +6000,7 @@
 </p:sld>
 </file>
 
-<file path=ppt/slides/slide12.xml><?xml version="1.0" encoding="utf-8"?>
+<file path=ppt/slides/slide11.xml><?xml version="1.0" encoding="utf-8"?>
 <p:sld xmlns:a="http://schemas.openxmlformats.org/drawingml/2006/main" xmlns:r="http://schemas.openxmlformats.org/officeDocument/2006/relationships" xmlns:p="http://schemas.openxmlformats.org/presentationml/2006/main">
   <p:cSld>
     <p:spTree>
@@ -7586,7 +6220,7 @@
           <a:p>
             <a:fld id="{254C963F-D690-449C-B336-8B464EE7B8DB}" type="slidenum">
               <a:rPr lang="pl-PL" smtClean="0"/>
-              <a:t>12</a:t>
+              <a:t>11</a:t>
             </a:fld>
             <a:endParaRPr lang="pl-PL" dirty="0"/>
           </a:p>
@@ -7650,7 +6284,7 @@
 </p:sld>
 </file>
 
-<file path=ppt/slides/slide13.xml><?xml version="1.0" encoding="utf-8"?>
+<file path=ppt/slides/slide12.xml><?xml version="1.0" encoding="utf-8"?>
 <p:sld xmlns:a="http://schemas.openxmlformats.org/drawingml/2006/main" xmlns:r="http://schemas.openxmlformats.org/officeDocument/2006/relationships" xmlns:p="http://schemas.openxmlformats.org/presentationml/2006/main">
   <p:cSld>
     <p:spTree>
@@ -7879,7 +6513,7 @@
           <a:p>
             <a:fld id="{254C963F-D690-449C-B336-8B464EE7B8DB}" type="slidenum">
               <a:rPr lang="pl-PL" smtClean="0"/>
-              <a:t>13</a:t>
+              <a:t>12</a:t>
             </a:fld>
             <a:endParaRPr lang="pl-PL" dirty="0"/>
           </a:p>
@@ -7946,7 +6580,7 @@
 </p:sld>
 </file>
 
-<file path=ppt/slides/slide14.xml><?xml version="1.0" encoding="utf-8"?>
+<file path=ppt/slides/slide13.xml><?xml version="1.0" encoding="utf-8"?>
 <p:sld xmlns:a="http://schemas.openxmlformats.org/drawingml/2006/main" xmlns:r="http://schemas.openxmlformats.org/officeDocument/2006/relationships" xmlns:p="http://schemas.openxmlformats.org/presentationml/2006/main">
   <p:cSld>
     <p:spTree>
@@ -8042,7 +6676,7 @@
           <a:p>
             <a:fld id="{254C963F-D690-449C-B336-8B464EE7B8DB}" type="slidenum">
               <a:rPr lang="pl-PL" smtClean="0"/>
-              <a:t>14</a:t>
+              <a:t>13</a:t>
             </a:fld>
             <a:endParaRPr lang="pl-PL" dirty="0"/>
           </a:p>
@@ -8073,7 +6707,7 @@
 </p:sld>
 </file>
 
-<file path=ppt/slides/slide15.xml><?xml version="1.0" encoding="utf-8"?>
+<file path=ppt/slides/slide14.xml><?xml version="1.0" encoding="utf-8"?>
 <p:sld xmlns:a="http://schemas.openxmlformats.org/drawingml/2006/main" xmlns:r="http://schemas.openxmlformats.org/officeDocument/2006/relationships" xmlns:p="http://schemas.openxmlformats.org/presentationml/2006/main">
   <p:cSld>
     <p:spTree>
@@ -8176,7 +6810,7 @@
           <a:p>
             <a:fld id="{254C963F-D690-449C-B336-8B464EE7B8DB}" type="slidenum">
               <a:rPr lang="pl-PL" smtClean="0"/>
-              <a:t>15</a:t>
+              <a:t>14</a:t>
             </a:fld>
             <a:endParaRPr lang="pl-PL" dirty="0"/>
           </a:p>
@@ -8235,7 +6869,7 @@
 </p:sld>
 </file>
 
-<file path=ppt/slides/slide16.xml><?xml version="1.0" encoding="utf-8"?>
+<file path=ppt/slides/slide15.xml><?xml version="1.0" encoding="utf-8"?>
 <p:sld xmlns:a="http://schemas.openxmlformats.org/drawingml/2006/main" xmlns:r="http://schemas.openxmlformats.org/officeDocument/2006/relationships" xmlns:p="http://schemas.openxmlformats.org/presentationml/2006/main">
   <p:cSld>
     <p:spTree>
@@ -8459,7 +7093,7 @@
           <a:p>
             <a:fld id="{254C963F-D690-449C-B336-8B464EE7B8DB}" type="slidenum">
               <a:rPr lang="pl-PL" smtClean="0"/>
-              <a:t>16</a:t>
+              <a:t>15</a:t>
             </a:fld>
             <a:endParaRPr lang="pl-PL" dirty="0"/>
           </a:p>
@@ -8548,7 +7182,7 @@
 </p:sld>
 </file>
 
-<file path=ppt/slides/slide17.xml><?xml version="1.0" encoding="utf-8"?>
+<file path=ppt/slides/slide16.xml><?xml version="1.0" encoding="utf-8"?>
 <p:sld xmlns:a="http://schemas.openxmlformats.org/drawingml/2006/main" xmlns:r="http://schemas.openxmlformats.org/officeDocument/2006/relationships" xmlns:p="http://schemas.openxmlformats.org/presentationml/2006/main">
   <p:cSld>
     <p:spTree>
@@ -8727,7 +7361,7 @@
           <a:p>
             <a:fld id="{254C963F-D690-449C-B336-8B464EE7B8DB}" type="slidenum">
               <a:rPr lang="pl-PL" smtClean="0"/>
-              <a:t>17</a:t>
+              <a:t>16</a:t>
             </a:fld>
             <a:endParaRPr lang="pl-PL" dirty="0"/>
           </a:p>
@@ -8863,7 +7497,7 @@
 </p:sld>
 </file>
 
-<file path=ppt/slides/slide18.xml><?xml version="1.0" encoding="utf-8"?>
+<file path=ppt/slides/slide17.xml><?xml version="1.0" encoding="utf-8"?>
 <p:sld xmlns:a="http://schemas.openxmlformats.org/drawingml/2006/main" xmlns:r="http://schemas.openxmlformats.org/officeDocument/2006/relationships" xmlns:p="http://schemas.openxmlformats.org/presentationml/2006/main">
   <p:cSld>
     <p:spTree>
@@ -9181,7 +7815,7 @@
           <a:p>
             <a:fld id="{254C963F-D690-449C-B336-8B464EE7B8DB}" type="slidenum">
               <a:rPr lang="pl-PL" smtClean="0"/>
-              <a:t>18</a:t>
+              <a:t>17</a:t>
             </a:fld>
             <a:endParaRPr lang="pl-PL" dirty="0"/>
           </a:p>
@@ -9287,7 +7921,7 @@
 </p:sld>
 </file>
 
-<file path=ppt/slides/slide19.xml><?xml version="1.0" encoding="utf-8"?>
+<file path=ppt/slides/slide18.xml><?xml version="1.0" encoding="utf-8"?>
 <p:sld xmlns:a="http://schemas.openxmlformats.org/drawingml/2006/main" xmlns:r="http://schemas.openxmlformats.org/officeDocument/2006/relationships" xmlns:p="http://schemas.openxmlformats.org/presentationml/2006/main">
   <p:cSld>
     <p:spTree>
@@ -9524,7 +8158,7 @@
           <a:p>
             <a:fld id="{254C963F-D690-449C-B336-8B464EE7B8DB}" type="slidenum">
               <a:rPr lang="pl-PL" smtClean="0"/>
-              <a:t>19</a:t>
+              <a:t>18</a:t>
             </a:fld>
             <a:endParaRPr lang="pl-PL" dirty="0"/>
           </a:p>
@@ -9596,6 +8230,240 @@
 </p:sld>
 </file>
 
+<file path=ppt/slides/slide19.xml><?xml version="1.0" encoding="utf-8"?>
+<p:sld xmlns:a="http://schemas.openxmlformats.org/drawingml/2006/main" xmlns:r="http://schemas.openxmlformats.org/officeDocument/2006/relationships" xmlns:p="http://schemas.openxmlformats.org/presentationml/2006/main">
+  <p:cSld>
+    <p:spTree>
+      <p:nvGrpSpPr>
+        <p:cNvPr id="1" name=""/>
+        <p:cNvGrpSpPr/>
+        <p:nvPr/>
+      </p:nvGrpSpPr>
+      <p:grpSpPr>
+        <a:xfrm>
+          <a:off x="0" y="0"/>
+          <a:ext cx="0" cy="0"/>
+          <a:chOff x="0" y="0"/>
+          <a:chExt cx="0" cy="0"/>
+        </a:xfrm>
+      </p:grpSpPr>
+      <p:sp>
+        <p:nvSpPr>
+          <p:cNvPr id="2" name="Symbol zastępczy zawartości 1">
+            <a:extLst>
+              <a:ext uri="{FF2B5EF4-FFF2-40B4-BE49-F238E27FC236}">
+                <a16:creationId xmlns:a16="http://schemas.microsoft.com/office/drawing/2014/main" id="{F9B3077B-F8DD-C67E-9F11-D4182C72C97A}"/>
+              </a:ext>
+            </a:extLst>
+          </p:cNvPr>
+          <p:cNvSpPr>
+            <a:spLocks noGrp="1"/>
+          </p:cNvSpPr>
+          <p:nvPr>
+            <p:ph idx="1"/>
+          </p:nvPr>
+        </p:nvSpPr>
+        <p:spPr/>
+        <p:txBody>
+          <a:bodyPr>
+            <a:normAutofit/>
+          </a:bodyPr>
+          <a:lstStyle/>
+          <a:p>
+            <a:pPr marL="514350" indent="-514350">
+              <a:buFont typeface="+mj-lt"/>
+              <a:buAutoNum type="arabicPeriod"/>
+            </a:pPr>
+            <a:r>
+              <a:rPr lang="en-US" dirty="0"/>
+              <a:t>In your local repository, open a folder</a:t>
+            </a:r>
+            <a:br>
+              <a:rPr lang="en-US" dirty="0"/>
+            </a:br>
+            <a:r>
+              <a:rPr lang="en-US" dirty="0">
+                <a:solidFill>
+                  <a:srgbClr val="00B0F0"/>
+                </a:solidFill>
+              </a:rPr>
+              <a:t>01-CourseIntroduction</a:t>
+            </a:r>
+          </a:p>
+          <a:p>
+            <a:pPr marL="514350" indent="-514350">
+              <a:buFont typeface="+mj-lt"/>
+              <a:buAutoNum type="arabicPeriod"/>
+            </a:pPr>
+            <a:r>
+              <a:rPr lang="en-US" dirty="0" err="1"/>
+              <a:t>Familiarise</a:t>
+            </a:r>
+            <a:r>
+              <a:rPr lang="en-US" dirty="0"/>
+              <a:t> yourself with the course syllabus</a:t>
+            </a:r>
+            <a:br>
+              <a:rPr lang="en-US" dirty="0"/>
+            </a:br>
+            <a:r>
+              <a:rPr lang="en-US" dirty="0">
+                <a:solidFill>
+                  <a:srgbClr val="00B0F0"/>
+                </a:solidFill>
+              </a:rPr>
+              <a:t>Syllabus.docx</a:t>
+            </a:r>
+          </a:p>
+          <a:p>
+            <a:pPr marL="514350" indent="-514350">
+              <a:buFont typeface="+mj-lt"/>
+              <a:buAutoNum type="arabicPeriod"/>
+            </a:pPr>
+            <a:r>
+              <a:rPr lang="pl-PL" dirty="0"/>
+              <a:t>F</a:t>
+            </a:r>
+            <a:r>
+              <a:rPr lang="en-US" dirty="0" err="1"/>
+              <a:t>ind</a:t>
+            </a:r>
+            <a:r>
+              <a:rPr lang="en-US" dirty="0"/>
+              <a:t> </a:t>
+            </a:r>
+            <a:r>
+              <a:rPr lang="pl-PL" dirty="0" err="1"/>
+              <a:t>course</a:t>
+            </a:r>
+            <a:r>
+              <a:rPr lang="pl-PL" dirty="0"/>
+              <a:t> </a:t>
+            </a:r>
+            <a:r>
+              <a:rPr lang="en-US" dirty="0"/>
+              <a:t>textbooks "Python for Everybody" (Polish and English versions). </a:t>
+            </a:r>
+            <a:r>
+              <a:rPr lang="pl-PL" dirty="0"/>
+              <a:t>Open </a:t>
+            </a:r>
+            <a:r>
+              <a:rPr lang="pl-PL" dirty="0" err="1"/>
+              <a:t>those</a:t>
+            </a:r>
+            <a:r>
+              <a:rPr lang="pl-PL" dirty="0"/>
+              <a:t> pdf </a:t>
+            </a:r>
+            <a:r>
+              <a:rPr lang="pl-PL" dirty="0" err="1"/>
+              <a:t>documents</a:t>
+            </a:r>
+            <a:r>
+              <a:rPr lang="pl-PL" dirty="0"/>
+              <a:t>. </a:t>
+            </a:r>
+            <a:r>
+              <a:rPr lang="en-US" dirty="0"/>
+              <a:t>Read the table of contents.</a:t>
+            </a:r>
+          </a:p>
+          <a:p>
+            <a:endParaRPr lang="en-US" dirty="0"/>
+          </a:p>
+        </p:txBody>
+      </p:sp>
+      <p:sp>
+        <p:nvSpPr>
+          <p:cNvPr id="3" name="Symbol zastępczy numeru slajdu 2">
+            <a:extLst>
+              <a:ext uri="{FF2B5EF4-FFF2-40B4-BE49-F238E27FC236}">
+                <a16:creationId xmlns:a16="http://schemas.microsoft.com/office/drawing/2014/main" id="{E04374CA-767F-9FAA-246B-BC2D212D8B7D}"/>
+              </a:ext>
+            </a:extLst>
+          </p:cNvPr>
+          <p:cNvSpPr>
+            <a:spLocks noGrp="1"/>
+          </p:cNvSpPr>
+          <p:nvPr>
+            <p:ph type="sldNum" sz="quarter" idx="12"/>
+          </p:nvPr>
+        </p:nvSpPr>
+        <p:spPr/>
+        <p:txBody>
+          <a:bodyPr/>
+          <a:lstStyle/>
+          <a:p>
+            <a:fld id="{254C963F-D690-449C-B336-8B464EE7B8DB}" type="slidenum">
+              <a:rPr lang="pl-PL" smtClean="0"/>
+              <a:t>19</a:t>
+            </a:fld>
+            <a:endParaRPr lang="pl-PL" dirty="0"/>
+          </a:p>
+        </p:txBody>
+      </p:sp>
+      <p:sp>
+        <p:nvSpPr>
+          <p:cNvPr id="4" name="Tytuł 3">
+            <a:extLst>
+              <a:ext uri="{FF2B5EF4-FFF2-40B4-BE49-F238E27FC236}">
+                <a16:creationId xmlns:a16="http://schemas.microsoft.com/office/drawing/2014/main" id="{B33793D8-279A-E713-D0D8-3D969606C585}"/>
+              </a:ext>
+            </a:extLst>
+          </p:cNvPr>
+          <p:cNvSpPr>
+            <a:spLocks noGrp="1"/>
+          </p:cNvSpPr>
+          <p:nvPr>
+            <p:ph type="title"/>
+          </p:nvPr>
+        </p:nvSpPr>
+        <p:spPr/>
+        <p:txBody>
+          <a:bodyPr/>
+          <a:lstStyle/>
+          <a:p>
+            <a:r>
+              <a:rPr lang="en-US" dirty="0"/>
+              <a:t>Read the </a:t>
+            </a:r>
+            <a:r>
+              <a:rPr lang="pl-PL" dirty="0"/>
+              <a:t>Course </a:t>
+            </a:r>
+            <a:r>
+              <a:rPr lang="en-US" dirty="0"/>
+              <a:t>Syllabus</a:t>
+            </a:r>
+          </a:p>
+        </p:txBody>
+      </p:sp>
+    </p:spTree>
+    <p:extLst>
+      <p:ext uri="{BB962C8B-B14F-4D97-AF65-F5344CB8AC3E}">
+        <p14:creationId xmlns:p14="http://schemas.microsoft.com/office/powerpoint/2010/main" val="1809690938"/>
+      </p:ext>
+    </p:extLst>
+  </p:cSld>
+  <p:clrMapOvr>
+    <a:masterClrMapping/>
+  </p:clrMapOvr>
+  <mc:AlternateContent xmlns:mc="http://schemas.openxmlformats.org/markup-compatibility/2006" xmlns:p14="http://schemas.microsoft.com/office/powerpoint/2010/main">
+    <mc:Choice Requires="p14">
+      <p:transition spd="slow" p14:dur="1200" advTm="31731">
+        <p14:prism/>
+      </p:transition>
+    </mc:Choice>
+    <mc:Fallback xmlns="">
+      <p:transition spd="slow" advTm="31731">
+        <p:fade/>
+      </p:transition>
+    </mc:Fallback>
+  </mc:AlternateContent>
+</p:sld>
+</file>
+
 <file path=ppt/slides/slide2.xml><?xml version="1.0" encoding="utf-8"?>
 <p:sld xmlns:a="http://schemas.openxmlformats.org/drawingml/2006/main" xmlns:r="http://schemas.openxmlformats.org/officeDocument/2006/relationships" xmlns:p="http://schemas.openxmlformats.org/presentationml/2006/main">
   <p:cSld>
@@ -9640,23 +8508,51 @@
               <a:buAutoNum type="arabicPeriod"/>
             </a:pPr>
             <a:r>
-              <a:rPr lang="pl-PL" dirty="0"/>
+              <a:rPr lang="pl-PL" dirty="0">
+                <a:highlight>
+                  <a:srgbClr val="00FF00"/>
+                </a:highlight>
+              </a:rPr>
               <a:t>C</a:t>
             </a:r>
             <a:r>
-              <a:rPr lang="en-US" dirty="0" err="1"/>
+              <a:rPr lang="en-US" dirty="0" err="1">
+                <a:highlight>
+                  <a:srgbClr val="00FF00"/>
+                </a:highlight>
+              </a:rPr>
               <a:t>ourse</a:t>
             </a:r>
             <a:r>
-              <a:rPr lang="en-US" dirty="0"/>
-              <a:t> forum on </a:t>
-            </a:r>
-            <a:r>
-              <a:rPr lang="pl-PL" dirty="0"/>
+              <a:rPr lang="en-US" dirty="0">
+                <a:highlight>
+                  <a:srgbClr val="00FF00"/>
+                </a:highlight>
+              </a:rPr>
+              <a:t> forum </a:t>
+            </a:r>
+            <a:r>
+              <a:rPr lang="en-US" b="0" dirty="0">
+                <a:highlight>
+                  <a:srgbClr val="00FF00"/>
+                </a:highlight>
+              </a:rPr>
+              <a:t>on </a:t>
+            </a:r>
+            <a:r>
+              <a:rPr lang="pl-PL" b="0" dirty="0">
+                <a:highlight>
+                  <a:srgbClr val="00FF00"/>
+                </a:highlight>
+              </a:rPr>
               <a:t>Microsoft </a:t>
             </a:r>
             <a:r>
-              <a:rPr lang="en-US" dirty="0"/>
+              <a:rPr lang="en-US" b="0" dirty="0">
+                <a:highlight>
+                  <a:srgbClr val="00FF00"/>
+                </a:highlight>
+              </a:rPr>
               <a:t>Teams</a:t>
             </a:r>
           </a:p>
@@ -9666,8 +8562,20 @@
               <a:buAutoNum type="arabicPeriod"/>
             </a:pPr>
             <a:r>
-              <a:rPr lang="en-US" dirty="0"/>
-              <a:t>Microsoft Teams chat</a:t>
+              <a:rPr lang="en-US" b="0" dirty="0">
+                <a:highlight>
+                  <a:srgbClr val="00FF00"/>
+                </a:highlight>
+              </a:rPr>
+              <a:t>Microsoft Teams </a:t>
+            </a:r>
+            <a:r>
+              <a:rPr lang="en-US" dirty="0">
+                <a:highlight>
+                  <a:srgbClr val="00FF00"/>
+                </a:highlight>
+              </a:rPr>
+              <a:t>chat</a:t>
             </a:r>
           </a:p>
           <a:p>
@@ -9681,9 +8589,13 @@
             </a:r>
             <a:r>
               <a:rPr lang="en-US" dirty="0"/>
-              <a:t>mail (details on teacher’s e-card)</a:t>
-            </a:r>
-            <a:endParaRPr lang="pl-PL" dirty="0"/>
+              <a:t>mail </a:t>
+            </a:r>
+            <a:r>
+              <a:rPr lang="en-US" b="0" dirty="0"/>
+              <a:t>(details on teacher’s e-card)</a:t>
+            </a:r>
+            <a:endParaRPr lang="pl-PL" b="0" dirty="0"/>
           </a:p>
           <a:p>
             <a:pPr marL="514350" indent="-514350">
@@ -9707,7 +8619,11 @@
             </a:r>
             <a:r>
               <a:rPr lang="en-US" dirty="0"/>
-              <a:t>ours (details on teacher’s e-card)</a:t>
+              <a:t>ours </a:t>
+            </a:r>
+            <a:r>
+              <a:rPr lang="en-US" b="0" dirty="0"/>
+              <a:t>(details on teacher’s e-card)</a:t>
             </a:r>
           </a:p>
           <a:p>
@@ -9862,240 +8778,6 @@
       </p:grpSpPr>
       <p:sp>
         <p:nvSpPr>
-          <p:cNvPr id="2" name="Symbol zastępczy zawartości 1">
-            <a:extLst>
-              <a:ext uri="{FF2B5EF4-FFF2-40B4-BE49-F238E27FC236}">
-                <a16:creationId xmlns:a16="http://schemas.microsoft.com/office/drawing/2014/main" id="{F9B3077B-F8DD-C67E-9F11-D4182C72C97A}"/>
-              </a:ext>
-            </a:extLst>
-          </p:cNvPr>
-          <p:cNvSpPr>
-            <a:spLocks noGrp="1"/>
-          </p:cNvSpPr>
-          <p:nvPr>
-            <p:ph idx="1"/>
-          </p:nvPr>
-        </p:nvSpPr>
-        <p:spPr/>
-        <p:txBody>
-          <a:bodyPr>
-            <a:normAutofit/>
-          </a:bodyPr>
-          <a:lstStyle/>
-          <a:p>
-            <a:pPr marL="514350" indent="-514350">
-              <a:buFont typeface="+mj-lt"/>
-              <a:buAutoNum type="arabicPeriod"/>
-            </a:pPr>
-            <a:r>
-              <a:rPr lang="en-US" dirty="0"/>
-              <a:t>In your local repository, open a folder</a:t>
-            </a:r>
-            <a:br>
-              <a:rPr lang="en-US" dirty="0"/>
-            </a:br>
-            <a:r>
-              <a:rPr lang="en-US" dirty="0">
-                <a:solidFill>
-                  <a:srgbClr val="00B0F0"/>
-                </a:solidFill>
-              </a:rPr>
-              <a:t>01-CourseIntroduction</a:t>
-            </a:r>
-          </a:p>
-          <a:p>
-            <a:pPr marL="514350" indent="-514350">
-              <a:buFont typeface="+mj-lt"/>
-              <a:buAutoNum type="arabicPeriod"/>
-            </a:pPr>
-            <a:r>
-              <a:rPr lang="en-US" dirty="0" err="1"/>
-              <a:t>Familiarise</a:t>
-            </a:r>
-            <a:r>
-              <a:rPr lang="en-US" dirty="0"/>
-              <a:t> yourself with the course syllabus</a:t>
-            </a:r>
-            <a:br>
-              <a:rPr lang="en-US" dirty="0"/>
-            </a:br>
-            <a:r>
-              <a:rPr lang="en-US" dirty="0">
-                <a:solidFill>
-                  <a:srgbClr val="00B0F0"/>
-                </a:solidFill>
-              </a:rPr>
-              <a:t>Syllabus.docx</a:t>
-            </a:r>
-          </a:p>
-          <a:p>
-            <a:pPr marL="514350" indent="-514350">
-              <a:buFont typeface="+mj-lt"/>
-              <a:buAutoNum type="arabicPeriod"/>
-            </a:pPr>
-            <a:r>
-              <a:rPr lang="pl-PL" dirty="0"/>
-              <a:t>F</a:t>
-            </a:r>
-            <a:r>
-              <a:rPr lang="en-US" dirty="0" err="1"/>
-              <a:t>ind</a:t>
-            </a:r>
-            <a:r>
-              <a:rPr lang="en-US" dirty="0"/>
-              <a:t> </a:t>
-            </a:r>
-            <a:r>
-              <a:rPr lang="pl-PL" dirty="0" err="1"/>
-              <a:t>course</a:t>
-            </a:r>
-            <a:r>
-              <a:rPr lang="pl-PL" dirty="0"/>
-              <a:t> </a:t>
-            </a:r>
-            <a:r>
-              <a:rPr lang="en-US" dirty="0"/>
-              <a:t>textbooks "Python for Everybody" (Polish and English versions). </a:t>
-            </a:r>
-            <a:r>
-              <a:rPr lang="pl-PL" dirty="0"/>
-              <a:t>Open </a:t>
-            </a:r>
-            <a:r>
-              <a:rPr lang="pl-PL" dirty="0" err="1"/>
-              <a:t>those</a:t>
-            </a:r>
-            <a:r>
-              <a:rPr lang="pl-PL" dirty="0"/>
-              <a:t> pdf </a:t>
-            </a:r>
-            <a:r>
-              <a:rPr lang="pl-PL" dirty="0" err="1"/>
-              <a:t>documents</a:t>
-            </a:r>
-            <a:r>
-              <a:rPr lang="pl-PL" dirty="0"/>
-              <a:t>. </a:t>
-            </a:r>
-            <a:r>
-              <a:rPr lang="en-US" dirty="0"/>
-              <a:t>Read the table of contents.</a:t>
-            </a:r>
-          </a:p>
-          <a:p>
-            <a:endParaRPr lang="en-US" dirty="0"/>
-          </a:p>
-        </p:txBody>
-      </p:sp>
-      <p:sp>
-        <p:nvSpPr>
-          <p:cNvPr id="3" name="Symbol zastępczy numeru slajdu 2">
-            <a:extLst>
-              <a:ext uri="{FF2B5EF4-FFF2-40B4-BE49-F238E27FC236}">
-                <a16:creationId xmlns:a16="http://schemas.microsoft.com/office/drawing/2014/main" id="{E04374CA-767F-9FAA-246B-BC2D212D8B7D}"/>
-              </a:ext>
-            </a:extLst>
-          </p:cNvPr>
-          <p:cNvSpPr>
-            <a:spLocks noGrp="1"/>
-          </p:cNvSpPr>
-          <p:nvPr>
-            <p:ph type="sldNum" sz="quarter" idx="12"/>
-          </p:nvPr>
-        </p:nvSpPr>
-        <p:spPr/>
-        <p:txBody>
-          <a:bodyPr/>
-          <a:lstStyle/>
-          <a:p>
-            <a:fld id="{254C963F-D690-449C-B336-8B464EE7B8DB}" type="slidenum">
-              <a:rPr lang="pl-PL" smtClean="0"/>
-              <a:t>20</a:t>
-            </a:fld>
-            <a:endParaRPr lang="pl-PL" dirty="0"/>
-          </a:p>
-        </p:txBody>
-      </p:sp>
-      <p:sp>
-        <p:nvSpPr>
-          <p:cNvPr id="4" name="Tytuł 3">
-            <a:extLst>
-              <a:ext uri="{FF2B5EF4-FFF2-40B4-BE49-F238E27FC236}">
-                <a16:creationId xmlns:a16="http://schemas.microsoft.com/office/drawing/2014/main" id="{B33793D8-279A-E713-D0D8-3D969606C585}"/>
-              </a:ext>
-            </a:extLst>
-          </p:cNvPr>
-          <p:cNvSpPr>
-            <a:spLocks noGrp="1"/>
-          </p:cNvSpPr>
-          <p:nvPr>
-            <p:ph type="title"/>
-          </p:nvPr>
-        </p:nvSpPr>
-        <p:spPr/>
-        <p:txBody>
-          <a:bodyPr/>
-          <a:lstStyle/>
-          <a:p>
-            <a:r>
-              <a:rPr lang="en-US" dirty="0"/>
-              <a:t>Read the </a:t>
-            </a:r>
-            <a:r>
-              <a:rPr lang="pl-PL" dirty="0"/>
-              <a:t>Course </a:t>
-            </a:r>
-            <a:r>
-              <a:rPr lang="en-US" dirty="0"/>
-              <a:t>Syllabus</a:t>
-            </a:r>
-          </a:p>
-        </p:txBody>
-      </p:sp>
-    </p:spTree>
-    <p:extLst>
-      <p:ext uri="{BB962C8B-B14F-4D97-AF65-F5344CB8AC3E}">
-        <p14:creationId xmlns:p14="http://schemas.microsoft.com/office/powerpoint/2010/main" val="1809690938"/>
-      </p:ext>
-    </p:extLst>
-  </p:cSld>
-  <p:clrMapOvr>
-    <a:masterClrMapping/>
-  </p:clrMapOvr>
-  <mc:AlternateContent xmlns:mc="http://schemas.openxmlformats.org/markup-compatibility/2006" xmlns:p14="http://schemas.microsoft.com/office/powerpoint/2010/main">
-    <mc:Choice Requires="p14">
-      <p:transition spd="slow" p14:dur="1200" advTm="31731">
-        <p14:prism/>
-      </p:transition>
-    </mc:Choice>
-    <mc:Fallback xmlns="">
-      <p:transition spd="slow" advTm="31731">
-        <p:fade/>
-      </p:transition>
-    </mc:Fallback>
-  </mc:AlternateContent>
-</p:sld>
-</file>
-
-<file path=ppt/slides/slide21.xml><?xml version="1.0" encoding="utf-8"?>
-<p:sld xmlns:a="http://schemas.openxmlformats.org/drawingml/2006/main" xmlns:r="http://schemas.openxmlformats.org/officeDocument/2006/relationships" xmlns:p="http://schemas.openxmlformats.org/presentationml/2006/main">
-  <p:cSld>
-    <p:spTree>
-      <p:nvGrpSpPr>
-        <p:cNvPr id="1" name=""/>
-        <p:cNvGrpSpPr/>
-        <p:nvPr/>
-      </p:nvGrpSpPr>
-      <p:grpSpPr>
-        <a:xfrm>
-          <a:off x="0" y="0"/>
-          <a:ext cx="0" cy="0"/>
-          <a:chOff x="0" y="0"/>
-          <a:chExt cx="0" cy="0"/>
-        </a:xfrm>
-      </p:grpSpPr>
-      <p:sp>
-        <p:nvSpPr>
           <p:cNvPr id="4" name="Tytuł 3">
             <a:extLst>
               <a:ext uri="{FF2B5EF4-FFF2-40B4-BE49-F238E27FC236}">
@@ -10317,7 +8999,7 @@
           <a:p>
             <a:fld id="{254C963F-D690-449C-B336-8B464EE7B8DB}" type="slidenum">
               <a:rPr lang="en-US" smtClean="0"/>
-              <a:t>21</a:t>
+              <a:t>20</a:t>
             </a:fld>
             <a:endParaRPr lang="en-US"/>
           </a:p>
@@ -11434,24 +10116,109 @@
           <a:bodyPr/>
           <a:lstStyle/>
           <a:p>
-            <a:pPr algn="ctr"/>
-            <a:endParaRPr lang="pl-PL" dirty="0"/>
-          </a:p>
-          <a:p>
-            <a:pPr algn="ctr"/>
-            <a:endParaRPr lang="pl-PL" dirty="0"/>
-          </a:p>
-          <a:p>
-            <a:pPr algn="ctr"/>
-            <a:r>
-              <a:rPr lang="pl-PL" sz="5400" dirty="0"/>
-              <a:t>Not </a:t>
-            </a:r>
-            <a:r>
-              <a:rPr lang="pl-PL" sz="5400" dirty="0" err="1"/>
-              <a:t>possible</a:t>
-            </a:r>
-            <a:endParaRPr lang="pl-PL" dirty="0"/>
+            <a:pPr marL="514350" indent="-514350">
+              <a:buFont typeface="+mj-lt"/>
+              <a:buAutoNum type="arabicPeriod"/>
+            </a:pPr>
+            <a:r>
+              <a:rPr lang="en-US" dirty="0"/>
+              <a:t>At the end of </a:t>
+            </a:r>
+            <a:r>
+              <a:rPr lang="pl-PL" dirty="0"/>
+              <a:t>the </a:t>
+            </a:r>
+            <a:r>
+              <a:rPr lang="en-US" dirty="0"/>
+              <a:t>semester</a:t>
+            </a:r>
+            <a:r>
+              <a:rPr lang="pl-PL" dirty="0"/>
+              <a:t> (~January)</a:t>
+            </a:r>
+            <a:endParaRPr lang="en-US" dirty="0"/>
+          </a:p>
+          <a:p>
+            <a:pPr marL="514350" indent="-514350">
+              <a:buFont typeface="+mj-lt"/>
+              <a:buAutoNum type="arabicPeriod"/>
+            </a:pPr>
+            <a:r>
+              <a:rPr lang="pl-PL" dirty="0" err="1"/>
+              <a:t>Absence</a:t>
+            </a:r>
+            <a:r>
+              <a:rPr lang="pl-PL" dirty="0"/>
+              <a:t> </a:t>
+            </a:r>
+            <a:r>
+              <a:rPr lang="pl-PL" dirty="0" err="1"/>
+              <a:t>has</a:t>
+            </a:r>
+            <a:r>
+              <a:rPr lang="pl-PL" dirty="0"/>
+              <a:t> to be c</a:t>
+            </a:r>
+            <a:r>
+              <a:rPr lang="en-US" dirty="0" err="1"/>
+              <a:t>onfirmed</a:t>
+            </a:r>
+            <a:r>
+              <a:rPr lang="en-US" dirty="0"/>
+              <a:t> by </a:t>
+            </a:r>
+            <a:r>
+              <a:rPr lang="pl-PL" dirty="0"/>
+              <a:t>a </a:t>
+            </a:r>
+            <a:r>
+              <a:rPr lang="en-US" dirty="0"/>
+              <a:t>sick </a:t>
+            </a:r>
+            <a:r>
+              <a:rPr lang="en-US" dirty="0" err="1"/>
+              <a:t>leav</a:t>
+            </a:r>
+            <a:r>
+              <a:rPr lang="pl-PL" dirty="0"/>
+              <a:t>e (</a:t>
+            </a:r>
+            <a:r>
+              <a:rPr lang="pl-PL" dirty="0" err="1">
+                <a:solidFill>
+                  <a:srgbClr val="FF0000"/>
+                </a:solidFill>
+              </a:rPr>
+              <a:t>within</a:t>
+            </a:r>
+            <a:r>
+              <a:rPr lang="pl-PL" dirty="0">
+                <a:solidFill>
+                  <a:srgbClr val="FF0000"/>
+                </a:solidFill>
+              </a:rPr>
+              <a:t> 7 </a:t>
+            </a:r>
+            <a:r>
+              <a:rPr lang="pl-PL" dirty="0" err="1">
+                <a:solidFill>
+                  <a:srgbClr val="FF0000"/>
+                </a:solidFill>
+              </a:rPr>
+              <a:t>days</a:t>
+            </a:r>
+            <a:r>
+              <a:rPr lang="pl-PL" dirty="0"/>
+              <a:t>)</a:t>
+            </a:r>
+            <a:endParaRPr lang="en-US" dirty="0"/>
+          </a:p>
+          <a:p>
+            <a:pPr marL="514350" indent="-514350">
+              <a:buFont typeface="+mj-lt"/>
+              <a:buAutoNum type="arabicPeriod"/>
+            </a:pPr>
+            <a:endParaRPr lang="en-US" dirty="0"/>
           </a:p>
         </p:txBody>
       </p:sp>
@@ -11479,245 +10246,6 @@
             <a:fld id="{254C963F-D690-449C-B336-8B464EE7B8DB}" type="slidenum">
               <a:rPr lang="pl-PL" smtClean="0"/>
               <a:t>6</a:t>
-            </a:fld>
-            <a:endParaRPr lang="pl-PL" dirty="0"/>
-          </a:p>
-        </p:txBody>
-      </p:sp>
-      <p:sp>
-        <p:nvSpPr>
-          <p:cNvPr id="4" name="Tytuł 3">
-            <a:extLst>
-              <a:ext uri="{FF2B5EF4-FFF2-40B4-BE49-F238E27FC236}">
-                <a16:creationId xmlns:a16="http://schemas.microsoft.com/office/drawing/2014/main" id="{1F28A227-2EE6-83AA-612F-04A8958950DA}"/>
-              </a:ext>
-            </a:extLst>
-          </p:cNvPr>
-          <p:cNvSpPr>
-            <a:spLocks noGrp="1"/>
-          </p:cNvSpPr>
-          <p:nvPr>
-            <p:ph type="title"/>
-          </p:nvPr>
-        </p:nvSpPr>
-        <p:spPr/>
-        <p:txBody>
-          <a:bodyPr/>
-          <a:lstStyle/>
-          <a:p>
-            <a:r>
-              <a:rPr lang="pl-PL" dirty="0"/>
-              <a:t>Test </a:t>
-            </a:r>
-            <a:r>
-              <a:rPr lang="pl-PL" dirty="0" err="1"/>
-              <a:t>Score</a:t>
-            </a:r>
-            <a:r>
-              <a:rPr lang="pl-PL" dirty="0"/>
-              <a:t> </a:t>
-            </a:r>
-            <a:r>
-              <a:rPr lang="pl-PL" dirty="0" err="1"/>
-              <a:t>Improvement</a:t>
-            </a:r>
-            <a:endParaRPr lang="pl-PL" dirty="0"/>
-          </a:p>
-        </p:txBody>
-      </p:sp>
-    </p:spTree>
-    <p:extLst>
-      <p:ext uri="{BB962C8B-B14F-4D97-AF65-F5344CB8AC3E}">
-        <p14:creationId xmlns:p14="http://schemas.microsoft.com/office/powerpoint/2010/main" val="3170683099"/>
-      </p:ext>
-    </p:extLst>
-  </p:cSld>
-  <p:clrMapOvr>
-    <a:masterClrMapping/>
-  </p:clrMapOvr>
-  <mc:AlternateContent xmlns:mc="http://schemas.openxmlformats.org/markup-compatibility/2006" xmlns:p14="http://schemas.microsoft.com/office/powerpoint/2010/main">
-    <mc:Choice Requires="p14">
-      <p:transition spd="slow" p14:dur="1200" advTm="33816">
-        <p14:prism/>
-      </p:transition>
-    </mc:Choice>
-    <mc:Fallback xmlns="">
-      <p:transition spd="slow" advTm="33816">
-        <p:fade/>
-      </p:transition>
-    </mc:Fallback>
-  </mc:AlternateContent>
-</p:sld>
-</file>
-
-<file path=ppt/slides/slide7.xml><?xml version="1.0" encoding="utf-8"?>
-<p:sld xmlns:a="http://schemas.openxmlformats.org/drawingml/2006/main" xmlns:r="http://schemas.openxmlformats.org/officeDocument/2006/relationships" xmlns:p="http://schemas.openxmlformats.org/presentationml/2006/main">
-  <p:cSld>
-    <p:spTree>
-      <p:nvGrpSpPr>
-        <p:cNvPr id="1" name=""/>
-        <p:cNvGrpSpPr/>
-        <p:nvPr/>
-      </p:nvGrpSpPr>
-      <p:grpSpPr>
-        <a:xfrm>
-          <a:off x="0" y="0"/>
-          <a:ext cx="0" cy="0"/>
-          <a:chOff x="0" y="0"/>
-          <a:chExt cx="0" cy="0"/>
-        </a:xfrm>
-      </p:grpSpPr>
-      <p:sp>
-        <p:nvSpPr>
-          <p:cNvPr id="2" name="Symbol zastępczy zawartości 1">
-            <a:extLst>
-              <a:ext uri="{FF2B5EF4-FFF2-40B4-BE49-F238E27FC236}">
-                <a16:creationId xmlns:a16="http://schemas.microsoft.com/office/drawing/2014/main" id="{323C843C-BB9F-F359-A3C4-389BFAB44E17}"/>
-              </a:ext>
-            </a:extLst>
-          </p:cNvPr>
-          <p:cNvSpPr>
-            <a:spLocks noGrp="1"/>
-          </p:cNvSpPr>
-          <p:nvPr>
-            <p:ph idx="1"/>
-          </p:nvPr>
-        </p:nvSpPr>
-        <p:spPr/>
-        <p:txBody>
-          <a:bodyPr/>
-          <a:lstStyle/>
-          <a:p>
-            <a:pPr marL="514350" indent="-514350">
-              <a:buFont typeface="+mj-lt"/>
-              <a:buAutoNum type="arabicPeriod"/>
-            </a:pPr>
-            <a:r>
-              <a:rPr lang="en-US" dirty="0"/>
-              <a:t>At the end of </a:t>
-            </a:r>
-            <a:r>
-              <a:rPr lang="pl-PL" dirty="0"/>
-              <a:t>the </a:t>
-            </a:r>
-            <a:r>
-              <a:rPr lang="en-US" dirty="0"/>
-              <a:t>semester</a:t>
-            </a:r>
-            <a:r>
-              <a:rPr lang="pl-PL" dirty="0"/>
-              <a:t> (~January)</a:t>
-            </a:r>
-            <a:endParaRPr lang="en-US" dirty="0"/>
-          </a:p>
-          <a:p>
-            <a:pPr marL="514350" indent="-514350">
-              <a:buFont typeface="+mj-lt"/>
-              <a:buAutoNum type="arabicPeriod"/>
-            </a:pPr>
-            <a:r>
-              <a:rPr lang="pl-PL" dirty="0" err="1"/>
-              <a:t>Absence</a:t>
-            </a:r>
-            <a:r>
-              <a:rPr lang="pl-PL" dirty="0"/>
-              <a:t> </a:t>
-            </a:r>
-            <a:r>
-              <a:rPr lang="pl-PL" dirty="0" err="1"/>
-              <a:t>has</a:t>
-            </a:r>
-            <a:r>
-              <a:rPr lang="pl-PL" dirty="0"/>
-              <a:t> to be c</a:t>
-            </a:r>
-            <a:r>
-              <a:rPr lang="en-US" dirty="0" err="1"/>
-              <a:t>onfirmed</a:t>
-            </a:r>
-            <a:r>
-              <a:rPr lang="en-US" dirty="0"/>
-              <a:t> by </a:t>
-            </a:r>
-            <a:r>
-              <a:rPr lang="pl-PL" dirty="0"/>
-              <a:t>a </a:t>
-            </a:r>
-            <a:r>
-              <a:rPr lang="en-US" dirty="0"/>
-              <a:t>sick </a:t>
-            </a:r>
-            <a:r>
-              <a:rPr lang="en-US" dirty="0" err="1"/>
-              <a:t>leav</a:t>
-            </a:r>
-            <a:r>
-              <a:rPr lang="pl-PL" dirty="0"/>
-              <a:t>e (</a:t>
-            </a:r>
-            <a:r>
-              <a:rPr lang="pl-PL" dirty="0" err="1">
-                <a:solidFill>
-                  <a:srgbClr val="FF0000"/>
-                </a:solidFill>
-              </a:rPr>
-              <a:t>within</a:t>
-            </a:r>
-            <a:r>
-              <a:rPr lang="pl-PL" dirty="0">
-                <a:solidFill>
-                  <a:srgbClr val="FF0000"/>
-                </a:solidFill>
-              </a:rPr>
-              <a:t> 7 </a:t>
-            </a:r>
-            <a:r>
-              <a:rPr lang="pl-PL" dirty="0" err="1">
-                <a:solidFill>
-                  <a:srgbClr val="FF0000"/>
-                </a:solidFill>
-              </a:rPr>
-              <a:t>days</a:t>
-            </a:r>
-            <a:r>
-              <a:rPr lang="pl-PL" dirty="0"/>
-              <a:t>)</a:t>
-            </a:r>
-            <a:endParaRPr lang="en-US" dirty="0"/>
-          </a:p>
-          <a:p>
-            <a:pPr marL="514350" indent="-514350">
-              <a:buFont typeface="+mj-lt"/>
-              <a:buAutoNum type="arabicPeriod"/>
-            </a:pPr>
-            <a:endParaRPr lang="en-US" dirty="0"/>
-          </a:p>
-        </p:txBody>
-      </p:sp>
-      <p:sp>
-        <p:nvSpPr>
-          <p:cNvPr id="3" name="Symbol zastępczy numeru slajdu 2">
-            <a:extLst>
-              <a:ext uri="{FF2B5EF4-FFF2-40B4-BE49-F238E27FC236}">
-                <a16:creationId xmlns:a16="http://schemas.microsoft.com/office/drawing/2014/main" id="{6D89C42E-F8EA-55DF-48A0-D634D5DC071D}"/>
-              </a:ext>
-            </a:extLst>
-          </p:cNvPr>
-          <p:cNvSpPr>
-            <a:spLocks noGrp="1"/>
-          </p:cNvSpPr>
-          <p:nvPr>
-            <p:ph type="sldNum" sz="quarter" idx="12"/>
-          </p:nvPr>
-        </p:nvSpPr>
-        <p:spPr/>
-        <p:txBody>
-          <a:bodyPr/>
-          <a:lstStyle/>
-          <a:p>
-            <a:fld id="{254C963F-D690-449C-B336-8B464EE7B8DB}" type="slidenum">
-              <a:rPr lang="pl-PL" smtClean="0"/>
-              <a:t>7</a:t>
             </a:fld>
             <a:endParaRPr lang="pl-PL" dirty="0"/>
           </a:p>
@@ -11789,7 +10317,7 @@
 </p:sld>
 </file>
 
-<file path=ppt/slides/slide8.xml><?xml version="1.0" encoding="utf-8"?>
+<file path=ppt/slides/slide7.xml><?xml version="1.0" encoding="utf-8"?>
 <p:sld xmlns:a="http://schemas.openxmlformats.org/drawingml/2006/main" xmlns:r="http://schemas.openxmlformats.org/officeDocument/2006/relationships" xmlns:p="http://schemas.openxmlformats.org/presentationml/2006/main">
   <p:cSld>
     <p:spTree>
@@ -12385,7 +10913,7 @@
           <a:p>
             <a:fld id="{254C963F-D690-449C-B336-8B464EE7B8DB}" type="slidenum">
               <a:rPr lang="en-US" smtClean="0"/>
-              <a:t>8</a:t>
+              <a:t>7</a:t>
             </a:fld>
             <a:endParaRPr lang="en-US"/>
           </a:p>
@@ -12444,7 +10972,7 @@
 </p:sld>
 </file>
 
-<file path=ppt/slides/slide9.xml><?xml version="1.0" encoding="utf-8"?>
+<file path=ppt/slides/slide8.xml><?xml version="1.0" encoding="utf-8"?>
 <p:sld xmlns:a="http://schemas.openxmlformats.org/drawingml/2006/main" xmlns:r="http://schemas.openxmlformats.org/officeDocument/2006/relationships" xmlns:p="http://schemas.openxmlformats.org/presentationml/2006/main">
   <p:cSld>
     <p:spTree>
@@ -12590,7 +11118,7 @@
           <a:p>
             <a:fld id="{254C963F-D690-449C-B336-8B464EE7B8DB}" type="slidenum">
               <a:rPr lang="pl-PL" smtClean="0"/>
-              <a:t>9</a:t>
+              <a:t>8</a:t>
             </a:fld>
             <a:endParaRPr lang="pl-PL" dirty="0"/>
           </a:p>
@@ -12614,6 +11142,219 @@
     </mc:Choice>
     <mc:Fallback xmlns="">
       <p:transition spd="slow" advTm="25721">
+        <p:fade/>
+      </p:transition>
+    </mc:Fallback>
+  </mc:AlternateContent>
+</p:sld>
+</file>
+
+<file path=ppt/slides/slide9.xml><?xml version="1.0" encoding="utf-8"?>
+<p:sld xmlns:a="http://schemas.openxmlformats.org/drawingml/2006/main" xmlns:r="http://schemas.openxmlformats.org/officeDocument/2006/relationships" xmlns:p="http://schemas.openxmlformats.org/presentationml/2006/main">
+  <p:cSld>
+    <p:spTree>
+      <p:nvGrpSpPr>
+        <p:cNvPr id="1" name=""/>
+        <p:cNvGrpSpPr/>
+        <p:nvPr/>
+      </p:nvGrpSpPr>
+      <p:grpSpPr>
+        <a:xfrm>
+          <a:off x="0" y="0"/>
+          <a:ext cx="0" cy="0"/>
+          <a:chOff x="0" y="0"/>
+          <a:chExt cx="0" cy="0"/>
+        </a:xfrm>
+      </p:grpSpPr>
+      <p:sp>
+        <p:nvSpPr>
+          <p:cNvPr id="6" name="Symbol zastępczy zawartości 5">
+            <a:extLst>
+              <a:ext uri="{FF2B5EF4-FFF2-40B4-BE49-F238E27FC236}">
+                <a16:creationId xmlns:a16="http://schemas.microsoft.com/office/drawing/2014/main" id="{3BEF4DD1-DF03-4BD7-972C-609EAA9D84FC}"/>
+              </a:ext>
+            </a:extLst>
+          </p:cNvPr>
+          <p:cNvSpPr>
+            <a:spLocks noGrp="1"/>
+          </p:cNvSpPr>
+          <p:nvPr>
+            <p:ph idx="1"/>
+          </p:nvPr>
+        </p:nvSpPr>
+        <p:spPr/>
+        <p:txBody>
+          <a:bodyPr>
+            <a:normAutofit/>
+          </a:bodyPr>
+          <a:lstStyle/>
+          <a:p>
+            <a:pPr marL="514350" indent="-514350">
+              <a:buFont typeface="+mj-lt"/>
+              <a:buAutoNum type="arabicPeriod"/>
+            </a:pPr>
+            <a:r>
+              <a:rPr lang="pl-PL" dirty="0"/>
+              <a:t>Run Microsoft </a:t>
+            </a:r>
+            <a:r>
+              <a:rPr lang="pl-PL" dirty="0" err="1"/>
+              <a:t>Teams</a:t>
+            </a:r>
+            <a:endParaRPr lang="pl-PL" dirty="0"/>
+          </a:p>
+          <a:p>
+            <a:pPr marL="514350" indent="-514350">
+              <a:buFont typeface="+mj-lt"/>
+              <a:buAutoNum type="arabicPeriod"/>
+            </a:pPr>
+            <a:r>
+              <a:rPr lang="en-US" dirty="0"/>
+              <a:t>Log in to your account</a:t>
+            </a:r>
+          </a:p>
+          <a:p>
+            <a:pPr marL="514350" indent="-514350">
+              <a:buFont typeface="+mj-lt"/>
+              <a:buAutoNum type="arabicPeriod"/>
+            </a:pPr>
+            <a:r>
+              <a:rPr lang="pl-PL" dirty="0"/>
+              <a:t>Display team list</a:t>
+            </a:r>
+          </a:p>
+          <a:p>
+            <a:pPr marL="514350" indent="-514350">
+              <a:buFont typeface="+mj-lt"/>
+              <a:buAutoNum type="arabicPeriod"/>
+            </a:pPr>
+            <a:r>
+              <a:rPr lang="pl-PL" dirty="0"/>
+              <a:t>Select „</a:t>
+            </a:r>
+            <a:r>
+              <a:rPr lang="pl-PL" dirty="0" err="1"/>
+              <a:t>join</a:t>
+            </a:r>
+            <a:r>
+              <a:rPr lang="pl-PL" dirty="0"/>
+              <a:t> a team”</a:t>
+            </a:r>
+          </a:p>
+          <a:p>
+            <a:pPr marL="514350" indent="-514350">
+              <a:buFont typeface="+mj-lt"/>
+              <a:buAutoNum type="arabicPeriod"/>
+            </a:pPr>
+            <a:r>
+              <a:rPr lang="pl-PL" dirty="0" err="1"/>
+              <a:t>Use</a:t>
+            </a:r>
+            <a:r>
+              <a:rPr lang="pl-PL" dirty="0"/>
+              <a:t> a team code</a:t>
+            </a:r>
+            <a:br>
+              <a:rPr lang="pl-PL" dirty="0"/>
+            </a:br>
+            <a:r>
+              <a:rPr lang="pl-PL" dirty="0">
+                <a:solidFill>
+                  <a:srgbClr val="00B0F0"/>
+                </a:solidFill>
+              </a:rPr>
+              <a:t>76wfate</a:t>
+            </a:r>
+          </a:p>
+        </p:txBody>
+      </p:sp>
+      <p:sp>
+        <p:nvSpPr>
+          <p:cNvPr id="4" name="Symbol zastępczy numeru slajdu 3">
+            <a:extLst>
+              <a:ext uri="{FF2B5EF4-FFF2-40B4-BE49-F238E27FC236}">
+                <a16:creationId xmlns:a16="http://schemas.microsoft.com/office/drawing/2014/main" id="{A9E7A3CE-C572-405A-92A2-0E1533B68464}"/>
+              </a:ext>
+            </a:extLst>
+          </p:cNvPr>
+          <p:cNvSpPr>
+            <a:spLocks noGrp="1"/>
+          </p:cNvSpPr>
+          <p:nvPr>
+            <p:ph type="sldNum" sz="quarter" idx="12"/>
+          </p:nvPr>
+        </p:nvSpPr>
+        <p:spPr/>
+        <p:txBody>
+          <a:bodyPr/>
+          <a:lstStyle/>
+          <a:p>
+            <a:fld id="{254C963F-D690-449C-B336-8B464EE7B8DB}" type="slidenum">
+              <a:rPr lang="en-US" smtClean="0"/>
+              <a:t>9</a:t>
+            </a:fld>
+            <a:endParaRPr lang="en-US" dirty="0"/>
+          </a:p>
+        </p:txBody>
+      </p:sp>
+      <p:sp>
+        <p:nvSpPr>
+          <p:cNvPr id="5" name="Tytuł 4">
+            <a:extLst>
+              <a:ext uri="{FF2B5EF4-FFF2-40B4-BE49-F238E27FC236}">
+                <a16:creationId xmlns:a16="http://schemas.microsoft.com/office/drawing/2014/main" id="{E5EAA86D-7FAF-4F5F-B693-8A5642336538}"/>
+              </a:ext>
+            </a:extLst>
+          </p:cNvPr>
+          <p:cNvSpPr>
+            <a:spLocks noGrp="1"/>
+          </p:cNvSpPr>
+          <p:nvPr>
+            <p:ph type="title"/>
+          </p:nvPr>
+        </p:nvSpPr>
+        <p:spPr/>
+        <p:txBody>
+          <a:bodyPr/>
+          <a:lstStyle/>
+          <a:p>
+            <a:r>
+              <a:rPr lang="en-US" dirty="0"/>
+              <a:t>Sign up for </a:t>
+            </a:r>
+            <a:r>
+              <a:rPr lang="pl-PL" dirty="0"/>
+              <a:t>C</a:t>
+            </a:r>
+            <a:r>
+              <a:rPr lang="en-US" dirty="0" err="1"/>
+              <a:t>ourse</a:t>
+            </a:r>
+            <a:r>
+              <a:rPr lang="en-US" dirty="0"/>
+              <a:t> on Teams</a:t>
+            </a:r>
+          </a:p>
+        </p:txBody>
+      </p:sp>
+    </p:spTree>
+    <p:extLst>
+      <p:ext uri="{BB962C8B-B14F-4D97-AF65-F5344CB8AC3E}">
+        <p14:creationId xmlns:p14="http://schemas.microsoft.com/office/powerpoint/2010/main" val="3207883656"/>
+      </p:ext>
+    </p:extLst>
+  </p:cSld>
+  <p:clrMapOvr>
+    <a:masterClrMapping/>
+  </p:clrMapOvr>
+  <mc:AlternateContent xmlns:mc="http://schemas.openxmlformats.org/markup-compatibility/2006" xmlns:p14="http://schemas.microsoft.com/office/powerpoint/2010/main">
+    <mc:Choice Requires="p14">
+      <p:transition spd="slow" p14:dur="1200" advTm="30614">
+        <p14:prism/>
+      </p:transition>
+    </mc:Choice>
+    <mc:Fallback xmlns="">
+      <p:transition spd="slow" advTm="30614">
         <p:fade/>
       </p:transition>
     </mc:Fallback>

</xml_diff>